<commit_message>
deck 3-0: visual QA pass on the kickoff
Title block now names itself the Act III kickoff instead of the
deployment lecture; the app-stack boxes widen so RESERVATION LOGIC
keeps its side padding; the slide-6 stack clears the panel border; the
method-flow captions sit closer to the arrows they annotate. Verified:
6 slides, TIMING 10 minutes, pptx_validate 0 OPC / 0 schema, clean
zip and CRC.

Co-Authored-By: Claude Opus 5 <noreply@anthropic.com>
</commit_message>
<xml_diff>
--- a/course/lectures/act-3-software-in-the-world/3-0-Act-III-Kickoff.pptx
+++ b/course/lectures/act-3-software-in-the-world/3-0-Act-III-Kickoff.pptx
@@ -5216,7 +5216,7 @@
                   <a:srgbClr val="000000"/>
                 </a:solidFill>
               </a:rPr>
-              <a:t>Compute Environments &amp; Deployment</a:t>
+              <a:t>The Act III kickoff</a:t>
             </a:r>
           </a:p>
           <a:p>
@@ -5590,7 +5590,7 @@
         <p:spPr>
           <a:xfrm>
             <a:off x="457200" y="1051560"/>
-            <a:ext cx="2377440" cy="685800"/>
+            <a:ext cx="2560320" cy="685800"/>
           </a:xfrm>
           <a:prstGeom prst="rect">
             <a:avLst/>
@@ -5642,7 +5642,7 @@
         <p:spPr>
           <a:xfrm>
             <a:off x="457200" y="1965960"/>
-            <a:ext cx="2377440" cy="685800"/>
+            <a:ext cx="2560320" cy="685800"/>
           </a:xfrm>
           <a:prstGeom prst="rect">
             <a:avLst/>
@@ -5693,7 +5693,7 @@
         </p:nvCxnSpPr>
         <p:spPr>
           <a:xfrm>
-            <a:off x="1645920" y="1737360"/>
+            <a:off x="1737360" y="1737360"/>
             <a:ext cx="0" cy="228600"/>
           </a:xfrm>
           <a:prstGeom prst="line">
@@ -5730,7 +5730,7 @@
         <p:spPr>
           <a:xfrm>
             <a:off x="457200" y="2880360"/>
-            <a:ext cx="2377440" cy="685800"/>
+            <a:ext cx="2560320" cy="685800"/>
           </a:xfrm>
           <a:prstGeom prst="rect">
             <a:avLst/>
@@ -5781,7 +5781,7 @@
         </p:nvCxnSpPr>
         <p:spPr>
           <a:xfrm>
-            <a:off x="1645920" y="2651760"/>
+            <a:off x="1737360" y="2651760"/>
             <a:ext cx="0" cy="228600"/>
           </a:xfrm>
           <a:prstGeom prst="line">
@@ -5818,7 +5818,7 @@
         <p:spPr>
           <a:xfrm>
             <a:off x="457200" y="3794760"/>
-            <a:ext cx="2377440" cy="685800"/>
+            <a:ext cx="2560320" cy="685800"/>
           </a:xfrm>
           <a:prstGeom prst="rect">
             <a:avLst/>
@@ -5869,7 +5869,7 @@
         </p:nvCxnSpPr>
         <p:spPr>
           <a:xfrm>
-            <a:off x="1645920" y="3566160"/>
+            <a:off x="1737360" y="3566160"/>
             <a:ext cx="0" cy="228600"/>
           </a:xfrm>
           <a:prstGeom prst="line">
@@ -7756,8 +7756,8 @@
           </p:nvSpPr>
           <p:spPr>
             <a:xfrm>
-              <a:off x="777240" y="3172968"/>
-              <a:ext cx="4361688" cy="384048"/>
+              <a:off x="777240" y="3255264"/>
+              <a:ext cx="4407408" cy="384048"/>
             </a:xfrm>
             <a:prstGeom prst="rect">
               <a:avLst/>
@@ -9283,8 +9283,8 @@
         </p:nvSpPr>
         <p:spPr>
           <a:xfrm>
-            <a:off x="731520" y="2011680"/>
-            <a:ext cx="2377440" cy="658368"/>
+            <a:off x="731520" y="1938528"/>
+            <a:ext cx="2468880" cy="658368"/>
           </a:xfrm>
           <a:prstGeom prst="rect">
             <a:avLst/>
@@ -9335,8 +9335,8 @@
         </p:nvSpPr>
         <p:spPr>
           <a:xfrm>
-            <a:off x="731520" y="2852928"/>
-            <a:ext cx="2377440" cy="658368"/>
+            <a:off x="731520" y="2761488"/>
+            <a:ext cx="2468880" cy="658368"/>
           </a:xfrm>
           <a:prstGeom prst="rect">
             <a:avLst/>
@@ -9387,8 +9387,8 @@
         </p:nvCxnSpPr>
         <p:spPr>
           <a:xfrm>
-            <a:off x="1920240" y="2633472"/>
-            <a:ext cx="0" cy="219456"/>
+            <a:off x="1965960" y="2596896"/>
+            <a:ext cx="0" cy="164592"/>
           </a:xfrm>
           <a:prstGeom prst="line">
             <a:avLst/>
@@ -9423,8 +9423,8 @@
         </p:nvSpPr>
         <p:spPr>
           <a:xfrm>
-            <a:off x="731520" y="3694176"/>
-            <a:ext cx="2377440" cy="658368"/>
+            <a:off x="731520" y="3584448"/>
+            <a:ext cx="2468880" cy="658368"/>
           </a:xfrm>
           <a:prstGeom prst="rect">
             <a:avLst/>
@@ -9475,8 +9475,8 @@
         </p:nvCxnSpPr>
         <p:spPr>
           <a:xfrm>
-            <a:off x="1920240" y="3474720"/>
-            <a:ext cx="0" cy="219456"/>
+            <a:off x="1965960" y="3419856"/>
+            <a:ext cx="0" cy="164592"/>
           </a:xfrm>
           <a:prstGeom prst="line">
             <a:avLst/>
@@ -9511,8 +9511,8 @@
         </p:nvSpPr>
         <p:spPr>
           <a:xfrm>
-            <a:off x="731520" y="4535424"/>
-            <a:ext cx="2377440" cy="658368"/>
+            <a:off x="731520" y="4407408"/>
+            <a:ext cx="2468880" cy="658368"/>
           </a:xfrm>
           <a:prstGeom prst="rect">
             <a:avLst/>
@@ -9563,8 +9563,8 @@
         </p:nvCxnSpPr>
         <p:spPr>
           <a:xfrm>
-            <a:off x="1920240" y="4315968"/>
-            <a:ext cx="0" cy="219456"/>
+            <a:off x="1965960" y="4242816"/>
+            <a:ext cx="0" cy="164592"/>
           </a:xfrm>
           <a:prstGeom prst="line">
             <a:avLst/>

</xml_diff>

<commit_message>
deck 3-0 author review P0: slide 4 explicit dual feedback paths; slide 5 judgment corrections
Slide 4: replace the three disjoint REVISE line segments with two single-shape
right-angle feedback paths, visually distinct and attached at both ends:
LOCAL REVISION (grey, Evidence -> Realize) and ENGINEERING REVISION (gold,
Evidence -> Model). Reword closing line to 'We will use this method throughout
Act III'; raise flowchart box type to 22pt; notes describe both paths.
Slide 5: Data judgment -> 'Which representation and guarantees do we need?'
(model -> 'data schema and invariants'); Architecture judgment -> 'Which
boundaries should we preserve or change?'; Performance judgment -> 'Which
change will improve performance?' (author's 'would consider' item, applied).
Rows re-pitched for two-line judgments; headers/topic/model cells 22pt.
Notes retimed: S3 1.5 / S4 3 / S5 1.5 (deck total stays 10).

Co-Authored-By: Claude Opus 5 <noreply@anthropic.com>
</commit_message>
<xml_diff>
--- a/course/lectures/act-3-software-in-the-world/3-0-Act-III-Kickoff.pptx
+++ b/course/lectures/act-3-software-in-the-world/3-0-Act-III-Kickoff.pptx
@@ -1257,7 +1257,7 @@
           <a:lstStyle/>
           <a:p>
             <a:r>
-              <a:t>TIMING: 2 minutes. ONE VISUAL, SIX UNITS — DO NOT DESCRIBE EACH UNIT.</a:t>
+              <a:t>TIMING: 1.5 minutes. ONE VISUAL, SIX UNITS — DO NOT DESCRIBE EACH UNIT.</a:t>
             </a:r>
           </a:p>
           <a:p>
@@ -1352,7 +1352,7 @@
           <a:lstStyle/>
           <a:p>
             <a:r>
-              <a:t>TIMING: 2 minutes. THE METHOD SLIDE — THE REUSABLE MOTIF FOR ALL OF ACT III. Later lectures re-show this exact flowchart with the current step highlighted; teach it carefully once so it never needs re-explaining.</a:t>
+              <a:t>TIMING: 3 minutes. THE METHOD SLIDE — THE REUSABLE MOTIF FOR ALL OF ACT III. Later lectures re-show this exact flowchart with the current step highlighted; teach it carefully once so it never needs re-explaining.</a:t>
             </a:r>
           </a:p>
           <a:p>
@@ -1362,7 +1362,7 @@
           </a:p>
           <a:p>
             <a:r>
-              <a:t>THE FEEDBACK ARROW: evidence that contradicts the model or the judgment sends us back — REVISE. Models are corrected by what deployment and operation teach.</a:t>
+              <a:t>THE TWO FEEDBACK PATHS: a LOCAL revision returns to Realize (the implementation was defective; try again). An ENGINEERING revision returns to the Model, and the judgment is re-made (the model or the decision itself was inadequate). Models are corrected by what deployment and operation teach.</a:t>
             </a:r>
           </a:p>
           <a:p>
@@ -1447,7 +1447,7 @@
           <a:lstStyle/>
           <a:p>
             <a:r>
-              <a:t>TIMING: 2 minutes. APPLY the method — do not re-explain it. The previous slide showed the loop; this one instantiates the Model and Judgment boxes for each unit of Act III.</a:t>
+              <a:t>TIMING: 1.5 minutes. APPLY the method — do not re-explain it. The previous slide showed the loop; this one instantiates the Model and Judgment boxes for each unit of Act III.</a:t>
             </a:r>
           </a:p>
           <a:p>
@@ -6996,7 +6996,7 @@
             <a:p>
               <a:pPr algn="ctr"/>
               <a:r>
-                <a:rPr sz="2000" b="1" i="0" dirty="0">
+                <a:rPr sz="2200" b="1" i="0" dirty="0">
                   <a:solidFill>
                     <a:srgbClr val="FFFFFF"/>
                   </a:solidFill>
@@ -7048,7 +7048,7 @@
             <a:p>
               <a:pPr algn="ctr"/>
               <a:r>
-                <a:rPr sz="2000" b="1" i="0" dirty="0">
+                <a:rPr sz="2200" b="1" i="0" dirty="0">
                   <a:solidFill>
                     <a:srgbClr val="FFFFFF"/>
                   </a:solidFill>
@@ -7100,7 +7100,7 @@
             <a:p>
               <a:pPr algn="ctr"/>
               <a:r>
-                <a:rPr sz="2000" b="1" i="0" dirty="0">
+                <a:rPr sz="2200" b="1" i="0" dirty="0">
                   <a:solidFill>
                     <a:srgbClr val="FFFFFF"/>
                   </a:solidFill>
@@ -7152,7 +7152,7 @@
             <a:p>
               <a:pPr algn="ctr"/>
               <a:r>
-                <a:rPr sz="2000" b="1" i="0" dirty="0">
+                <a:rPr sz="2200" b="1" i="0" dirty="0">
                   <a:solidFill>
                     <a:srgbClr val="FFFFFF"/>
                   </a:solidFill>
@@ -7204,7 +7204,7 @@
             <a:p>
               <a:pPr algn="ctr"/>
               <a:r>
-                <a:rPr sz="2000" b="1" i="0" dirty="0">
+                <a:rPr sz="2200" b="1" i="0" dirty="0">
                   <a:solidFill>
                     <a:srgbClr val="FFFFFF"/>
                   </a:solidFill>
@@ -7256,7 +7256,7 @@
             <a:p>
               <a:pPr algn="ctr"/>
               <a:r>
-                <a:rPr sz="2000" b="1" i="0" dirty="0">
+                <a:rPr sz="2200" b="1" i="0" dirty="0">
                   <a:solidFill>
                     <a:srgbClr val="FFFFFF"/>
                   </a:solidFill>
@@ -7267,7 +7267,7 @@
             <a:p>
               <a:pPr algn="ctr"/>
               <a:r>
-                <a:rPr sz="2000" b="1" i="0" dirty="0">
+                <a:rPr sz="2200" b="1" i="0" dirty="0">
                   <a:solidFill>
                     <a:srgbClr val="FFFFFF"/>
                   </a:solidFill>
@@ -7457,162 +7457,6 @@
             </a:fontRef>
           </p:style>
         </p:cxnSp>
-        <p:cxnSp>
-          <p:nvCxnSpPr>
-            <p:cNvPr id="1014" name="Revise up"/>
-            <p:cNvCxnSpPr/>
-            <p:nvPr/>
-          </p:nvCxnSpPr>
-          <p:spPr>
-            <a:xfrm flipV="1">
-              <a:off x="6757416" y="1554480"/>
-              <a:ext cx="0" cy="594360"/>
-            </a:xfrm>
-            <a:prstGeom prst="line">
-              <a:avLst/>
-            </a:prstGeom>
-            <a:ln w="19050">
-              <a:solidFill>
-                <a:srgbClr val="8E6F3E"/>
-              </a:solidFill>
-            </a:ln>
-          </p:spPr>
-          <p:style>
-            <a:lnRef idx="2">
-              <a:schemeClr val="accent1"/>
-            </a:lnRef>
-            <a:fillRef idx="0">
-              <a:schemeClr val="accent1"/>
-            </a:fillRef>
-            <a:effectRef idx="1">
-              <a:schemeClr val="accent1"/>
-            </a:effectRef>
-            <a:fontRef idx="minor">
-              <a:schemeClr val="tx1"/>
-            </a:fontRef>
-          </p:style>
-        </p:cxnSp>
-        <p:cxnSp>
-          <p:nvCxnSpPr>
-            <p:cNvPr id="1015" name="Revise across"/>
-            <p:cNvCxnSpPr/>
-            <p:nvPr/>
-          </p:nvCxnSpPr>
-          <p:spPr>
-            <a:xfrm>
-              <a:off x="2395728" y="1554480"/>
-              <a:ext cx="4361688" cy="0"/>
-            </a:xfrm>
-            <a:prstGeom prst="line">
-              <a:avLst/>
-            </a:prstGeom>
-            <a:ln w="19050">
-              <a:solidFill>
-                <a:srgbClr val="8E6F3E"/>
-              </a:solidFill>
-            </a:ln>
-          </p:spPr>
-          <p:style>
-            <a:lnRef idx="2">
-              <a:schemeClr val="accent1"/>
-            </a:lnRef>
-            <a:fillRef idx="0">
-              <a:schemeClr val="accent1"/>
-            </a:fillRef>
-            <a:effectRef idx="1">
-              <a:schemeClr val="accent1"/>
-            </a:effectRef>
-            <a:fontRef idx="minor">
-              <a:schemeClr val="tx1"/>
-            </a:fontRef>
-          </p:style>
-        </p:cxnSp>
-        <p:cxnSp>
-          <p:nvCxnSpPr>
-            <p:cNvPr id="1016" name="Revise down"/>
-            <p:cNvCxnSpPr/>
-            <p:nvPr/>
-          </p:nvCxnSpPr>
-          <p:spPr>
-            <a:xfrm>
-              <a:off x="2395728" y="1554480"/>
-              <a:ext cx="0" cy="594360"/>
-            </a:xfrm>
-            <a:prstGeom prst="line">
-              <a:avLst/>
-            </a:prstGeom>
-            <a:ln w="19050">
-              <a:solidFill>
-                <a:srgbClr val="8E6F3E"/>
-              </a:solidFill>
-              <a:tailEnd type="triangle"/>
-            </a:ln>
-          </p:spPr>
-          <p:style>
-            <a:lnRef idx="2">
-              <a:schemeClr val="accent1"/>
-            </a:lnRef>
-            <a:fillRef idx="0">
-              <a:schemeClr val="accent1"/>
-            </a:fillRef>
-            <a:effectRef idx="1">
-              <a:schemeClr val="accent1"/>
-            </a:effectRef>
-            <a:fontRef idx="minor">
-              <a:schemeClr val="tx1"/>
-            </a:fontRef>
-          </p:style>
-        </p:cxnSp>
-        <p:sp>
-          <p:nvSpPr>
-            <p:cNvPr id="1017" name="Revise label"/>
-            <p:cNvSpPr/>
-            <p:nvPr/>
-          </p:nvSpPr>
-          <p:spPr>
-            <a:xfrm>
-              <a:off x="3840480" y="1152144"/>
-              <a:ext cx="1645920" cy="365760"/>
-            </a:xfrm>
-            <a:prstGeom prst="rect">
-              <a:avLst/>
-            </a:prstGeom>
-            <a:noFill/>
-            <a:ln>
-              <a:noFill/>
-            </a:ln>
-            <a:effectLst/>
-          </p:spPr>
-          <p:style>
-            <a:lnRef idx="1">
-              <a:schemeClr val="accent1"/>
-            </a:lnRef>
-            <a:fillRef idx="3">
-              <a:schemeClr val="accent1"/>
-            </a:fillRef>
-            <a:effectRef idx="2">
-              <a:schemeClr val="accent1"/>
-            </a:effectRef>
-            <a:fontRef idx="minor">
-              <a:schemeClr val="lt1"/>
-            </a:fontRef>
-          </p:style>
-          <p:txBody>
-            <a:bodyPr wrap="square" lIns="27432" tIns="22860" rIns="27432" bIns="22860" rtlCol="0" anchor="ctr"/>
-            <a:lstStyle/>
-            <a:p>
-              <a:pPr algn="ctr"/>
-              <a:r>
-                <a:rPr sz="2000" b="1" i="0" dirty="0">
-                  <a:solidFill>
-                    <a:srgbClr val="555960"/>
-                  </a:solidFill>
-                </a:rPr>
-                <a:t>REVISE</a:t>
-              </a:r>
-            </a:p>
-          </p:txBody>
-        </p:sp>
         <p:sp>
           <p:nvSpPr>
             <p:cNvPr id="1018" name="Method Alignment"/>
@@ -7655,7 +7499,7 @@
             <a:p>
               <a:pPr algn="ctr"/>
               <a:r>
-                <a:rPr sz="2000" b="1" i="0" dirty="0">
+                <a:rPr sz="2200" b="1" i="0" dirty="0">
                   <a:solidFill>
                     <a:srgbClr val="FFFFFF"/>
                   </a:solidFill>
@@ -7666,7 +7510,7 @@
             <a:p>
               <a:pPr algn="ctr"/>
               <a:r>
-                <a:rPr sz="2000" b="0" i="0" dirty="0">
+                <a:rPr sz="2200" b="0" i="0" dirty="0">
                   <a:solidFill>
                     <a:srgbClr val="FFFFFF"/>
                   </a:solidFill>
@@ -7889,12 +7733,176 @@
           <a:p>
             <a:pPr algn="ctr"/>
             <a:r>
-              <a:rPr sz="2000" b="0" i="1" dirty="0">
+              <a:rPr sz="2200" b="0" i="1" dirty="0">
                 <a:solidFill>
                   <a:srgbClr val="5C4826"/>
                 </a:solidFill>
               </a:rPr>
-              <a:t>This loop returns in every lecture of Act III</a:t>
+              <a:t>We will use this method throughout Act III</a:t>
+            </a:r>
+          </a:p>
+        </p:txBody>
+      </p:sp>
+      <p:sp>
+        <p:nvSpPr>
+          <p:cNvPr id="1101" name="Local revision path"/>
+          <p:cNvSpPr/>
+          <p:nvPr/>
+        </p:nvSpPr>
+        <p:spPr>
+          <a:xfrm>
+            <a:off x="5303520" y="1783080"/>
+            <a:ext cx="1197864" cy="365760"/>
+          </a:xfrm>
+          <a:custGeom>
+            <a:avLst/>
+            <a:gdLst/>
+            <a:ahLst/>
+            <a:cxnLst/>
+            <a:pathLst>
+              <a:path w="1197864" h="365760" fill="none">
+                <a:moveTo>
+                  <a:pt x="1197864" y="365760"/>
+                </a:moveTo>
+                <a:lnTo>
+                  <a:pt x="1197864" y="0"/>
+                </a:lnTo>
+                <a:lnTo>
+                  <a:pt x="0" y="0"/>
+                </a:lnTo>
+                <a:lnTo>
+                  <a:pt x="0" y="365760"/>
+                </a:lnTo>
+              </a:path>
+            </a:pathLst>
+          </a:custGeom>
+          <a:noFill/>
+          <a:ln w="19050">
+            <a:solidFill>
+              <a:srgbClr val="555960"/>
+            </a:solidFill>
+            <a:tailEnd type="triangle"/>
+          </a:ln>
+        </p:spPr>
+        <p:txBody>
+          <a:bodyPr wrap="square" rtlCol="0"/>
+          <a:lstStyle/>
+          <a:p/>
+        </p:txBody>
+      </p:sp>
+      <p:sp>
+        <p:nvSpPr>
+          <p:cNvPr id="1102" name="Engineering revision path"/>
+          <p:cNvSpPr/>
+          <p:nvPr/>
+        </p:nvSpPr>
+        <p:spPr>
+          <a:xfrm>
+            <a:off x="2395728" y="1298448"/>
+            <a:ext cx="4617720" cy="850392"/>
+          </a:xfrm>
+          <a:custGeom>
+            <a:avLst/>
+            <a:gdLst/>
+            <a:ahLst/>
+            <a:cxnLst/>
+            <a:pathLst>
+              <a:path w="4617720" h="850392" fill="none">
+                <a:moveTo>
+                  <a:pt x="4617720" y="850392"/>
+                </a:moveTo>
+                <a:lnTo>
+                  <a:pt x="4617720" y="0"/>
+                </a:lnTo>
+                <a:lnTo>
+                  <a:pt x="0" y="0"/>
+                </a:lnTo>
+                <a:lnTo>
+                  <a:pt x="0" y="850392"/>
+                </a:lnTo>
+              </a:path>
+            </a:pathLst>
+          </a:custGeom>
+          <a:noFill/>
+          <a:ln w="19050">
+            <a:solidFill>
+              <a:srgbClr val="8E6F3E"/>
+            </a:solidFill>
+            <a:tailEnd type="triangle"/>
+          </a:ln>
+        </p:spPr>
+        <p:txBody>
+          <a:bodyPr wrap="square" rtlCol="0"/>
+          <a:lstStyle/>
+          <a:p/>
+        </p:txBody>
+      </p:sp>
+      <p:sp>
+        <p:nvSpPr>
+          <p:cNvPr id="1103" name="Engineering revision label"/>
+          <p:cNvSpPr/>
+          <p:nvPr/>
+        </p:nvSpPr>
+        <p:spPr>
+          <a:xfrm>
+            <a:off x="868680" y="841248"/>
+            <a:ext cx="7680960" cy="347472"/>
+          </a:xfrm>
+          <a:prstGeom prst="rect">
+            <a:avLst/>
+          </a:prstGeom>
+          <a:noFill/>
+          <a:ln>
+            <a:noFill/>
+          </a:ln>
+        </p:spPr>
+        <p:txBody>
+          <a:bodyPr wrap="square" lIns="27432" tIns="11430" rIns="27432" bIns="11430" rtlCol="0" anchor="ctr"/>
+          <a:lstStyle/>
+          <a:p>
+            <a:pPr algn="ctr"/>
+            <a:r>
+              <a:rPr sz="2000" b="1" i="0" dirty="0">
+                <a:solidFill>
+                  <a:srgbClr val="8E6F3E"/>
+                </a:solidFill>
+              </a:rPr>
+              <a:t>ENGINEERING REVISION: rethink the model or the judgment</a:t>
+            </a:r>
+          </a:p>
+        </p:txBody>
+      </p:sp>
+      <p:sp>
+        <p:nvSpPr>
+          <p:cNvPr id="1104" name="Local revision label"/>
+          <p:cNvSpPr/>
+          <p:nvPr/>
+        </p:nvSpPr>
+        <p:spPr>
+          <a:xfrm>
+            <a:off x="2560320" y="1371600"/>
+            <a:ext cx="3886200" cy="329184"/>
+          </a:xfrm>
+          <a:prstGeom prst="rect">
+            <a:avLst/>
+          </a:prstGeom>
+          <a:noFill/>
+          <a:ln>
+            <a:noFill/>
+          </a:ln>
+        </p:spPr>
+        <p:txBody>
+          <a:bodyPr wrap="square" lIns="27432" tIns="11430" rIns="27432" bIns="11430" rtlCol="0" anchor="ctr"/>
+          <a:lstStyle/>
+          <a:p>
+            <a:pPr algn="r"/>
+            <a:r>
+              <a:rPr sz="2000" b="1" i="0" dirty="0">
+                <a:solidFill>
+                  <a:srgbClr val="555960"/>
+                </a:solidFill>
+              </a:rPr>
+              <a:t>LOCAL REVISION: fix the realization</a:t>
             </a:r>
           </a:p>
         </p:txBody>
@@ -7975,7 +7983,7 @@
         </p:nvSpPr>
         <p:spPr>
           <a:xfrm>
-            <a:off x="320040" y="914400"/>
+            <a:off x="320040" y="896112"/>
             <a:ext cx="1783080" cy="365760"/>
           </a:xfrm>
           <a:prstGeom prst="rect">
@@ -8007,7 +8015,7 @@
           <a:p>
             <a:pPr algn="l"/>
             <a:r>
-              <a:rPr sz="2000" b="1" i="0" dirty="0">
+              <a:rPr sz="2200" b="1" i="0" dirty="0">
                 <a:solidFill>
                   <a:srgbClr val="5C4826"/>
                 </a:solidFill>
@@ -8025,7 +8033,7 @@
         </p:nvSpPr>
         <p:spPr>
           <a:xfrm>
-            <a:off x="2240280" y="914400"/>
+            <a:off x="2240280" y="896112"/>
             <a:ext cx="2971800" cy="365760"/>
           </a:xfrm>
           <a:prstGeom prst="rect">
@@ -8057,7 +8065,7 @@
           <a:p>
             <a:pPr algn="l"/>
             <a:r>
-              <a:rPr sz="2000" b="1" i="0" dirty="0">
+              <a:rPr sz="2200" b="1" i="0" dirty="0">
                 <a:solidFill>
                   <a:srgbClr val="5C4826"/>
                 </a:solidFill>
@@ -8075,7 +8083,7 @@
         </p:nvSpPr>
         <p:spPr>
           <a:xfrm>
-            <a:off x="5349240" y="914400"/>
+            <a:off x="5349240" y="896112"/>
             <a:ext cx="3474720" cy="365760"/>
           </a:xfrm>
           <a:prstGeom prst="rect">
@@ -8107,7 +8115,7 @@
           <a:p>
             <a:pPr algn="l"/>
             <a:r>
-              <a:rPr sz="2000" b="1" i="0" dirty="0">
+              <a:rPr sz="2200" b="1" i="0" dirty="0">
                 <a:solidFill>
                   <a:srgbClr val="5C4826"/>
                 </a:solidFill>
@@ -8125,8 +8133,8 @@
         </p:nvSpPr>
         <p:spPr>
           <a:xfrm>
-            <a:off x="320040" y="1371600"/>
-            <a:ext cx="1783080" cy="502920"/>
+            <a:off x="320040" y="1316736"/>
+            <a:ext cx="1783080" cy="658368"/>
           </a:xfrm>
           <a:prstGeom prst="rect">
             <a:avLst/>
@@ -8159,7 +8167,7 @@
           <a:p>
             <a:pPr algn="ctr"/>
             <a:r>
-              <a:rPr sz="2000" b="1" i="0" dirty="0">
+              <a:rPr sz="2200" b="1" i="0" dirty="0">
                 <a:solidFill>
                   <a:srgbClr val="FFFFFF"/>
                 </a:solidFill>
@@ -8177,8 +8185,8 @@
         </p:nvSpPr>
         <p:spPr>
           <a:xfrm>
-            <a:off x="2240280" y="1371600"/>
-            <a:ext cx="2971800" cy="502920"/>
+            <a:off x="2240280" y="1316736"/>
+            <a:ext cx="2971800" cy="658368"/>
           </a:xfrm>
           <a:prstGeom prst="rect">
             <a:avLst/>
@@ -8213,7 +8221,7 @@
           <a:p>
             <a:pPr algn="ctr"/>
             <a:r>
-              <a:rPr sz="2000" b="0" i="0" dirty="0">
+              <a:rPr sz="2200" b="0" i="0" dirty="0">
                 <a:solidFill>
                   <a:srgbClr val="5C4826"/>
                 </a:solidFill>
@@ -8231,8 +8239,8 @@
         </p:nvSpPr>
         <p:spPr>
           <a:xfrm>
-            <a:off x="5349240" y="1435608"/>
-            <a:ext cx="3474720" cy="384048"/>
+            <a:off x="5349240" y="1316736"/>
+            <a:ext cx="3474720" cy="658368"/>
           </a:xfrm>
           <a:prstGeom prst="rect">
             <a:avLst/>
@@ -8258,7 +8266,7 @@
           </a:fontRef>
         </p:style>
         <p:txBody>
-          <a:bodyPr wrap="square" lIns="27432" tIns="22860" rIns="27432" bIns="22860" rtlCol="0" anchor="ctr"/>
+          <a:bodyPr wrap="square" lIns="27432" tIns="0" rIns="27432" bIns="0" rtlCol="0" anchor="ctr"/>
           <a:lstStyle/>
           <a:p>
             <a:pPr algn="l"/>
@@ -8281,8 +8289,8 @@
         </p:nvSpPr>
         <p:spPr>
           <a:xfrm>
-            <a:off x="320040" y="1947672"/>
-            <a:ext cx="1783080" cy="502920"/>
+            <a:off x="320040" y="2048256"/>
+            <a:ext cx="1783080" cy="658368"/>
           </a:xfrm>
           <a:prstGeom prst="rect">
             <a:avLst/>
@@ -8317,7 +8325,7 @@
           <a:p>
             <a:pPr algn="ctr"/>
             <a:r>
-              <a:rPr sz="2000" b="1" i="0" dirty="0">
+              <a:rPr sz="2200" b="1" i="0" dirty="0">
                 <a:solidFill>
                   <a:srgbClr val="5C4826"/>
                 </a:solidFill>
@@ -8335,8 +8343,8 @@
         </p:nvSpPr>
         <p:spPr>
           <a:xfrm>
-            <a:off x="2240280" y="1947672"/>
-            <a:ext cx="2971800" cy="502920"/>
+            <a:off x="2240280" y="2048256"/>
+            <a:ext cx="2971800" cy="658368"/>
           </a:xfrm>
           <a:prstGeom prst="rect">
             <a:avLst/>
@@ -8371,12 +8379,12 @@
           <a:p>
             <a:pPr algn="ctr"/>
             <a:r>
-              <a:rPr sz="2000" b="0" i="0" dirty="0">
+              <a:rPr sz="2200" b="0" i="0" dirty="0">
                 <a:solidFill>
                   <a:srgbClr val="5C4826"/>
                 </a:solidFill>
               </a:rPr>
-              <a:t>relational schema</a:t>
+              <a:t>data schema and invariants</a:t>
             </a:r>
           </a:p>
         </p:txBody>
@@ -8389,8 +8397,8 @@
         </p:nvSpPr>
         <p:spPr>
           <a:xfrm>
-            <a:off x="5349240" y="2011680"/>
-            <a:ext cx="3474720" cy="384048"/>
+            <a:off x="5349240" y="2048256"/>
+            <a:ext cx="3474720" cy="658368"/>
           </a:xfrm>
           <a:prstGeom prst="rect">
             <a:avLst/>
@@ -8416,7 +8424,7 @@
           </a:fontRef>
         </p:style>
         <p:txBody>
-          <a:bodyPr wrap="square" lIns="27432" tIns="22860" rIns="27432" bIns="22860" rtlCol="0" anchor="ctr"/>
+          <a:bodyPr wrap="square" lIns="27432" tIns="0" rIns="27432" bIns="0" rtlCol="0" anchor="ctr"/>
           <a:lstStyle/>
           <a:p>
             <a:pPr algn="l"/>
@@ -8426,7 +8434,7 @@
                   <a:srgbClr val="555960"/>
                 </a:solidFill>
               </a:rPr>
-              <a:t>What must survive?</a:t>
+              <a:t>Which representation and guarantees do we need?</a:t>
             </a:r>
           </a:p>
         </p:txBody>
@@ -8439,8 +8447,8 @@
         </p:nvSpPr>
         <p:spPr>
           <a:xfrm>
-            <a:off x="320040" y="2523744"/>
-            <a:ext cx="1783080" cy="502920"/>
+            <a:off x="320040" y="2779776"/>
+            <a:ext cx="1783080" cy="658368"/>
           </a:xfrm>
           <a:prstGeom prst="rect">
             <a:avLst/>
@@ -8475,7 +8483,7 @@
           <a:p>
             <a:pPr algn="ctr"/>
             <a:r>
-              <a:rPr sz="2000" b="1" i="0" dirty="0">
+              <a:rPr sz="2200" b="1" i="0" dirty="0">
                 <a:solidFill>
                   <a:srgbClr val="5C4826"/>
                 </a:solidFill>
@@ -8493,8 +8501,8 @@
         </p:nvSpPr>
         <p:spPr>
           <a:xfrm>
-            <a:off x="2240280" y="2523744"/>
-            <a:ext cx="2971800" cy="502920"/>
+            <a:off x="2240280" y="2779776"/>
+            <a:ext cx="2971800" cy="658368"/>
           </a:xfrm>
           <a:prstGeom prst="rect">
             <a:avLst/>
@@ -8529,7 +8537,7 @@
           <a:p>
             <a:pPr algn="ctr"/>
             <a:r>
-              <a:rPr sz="2000" b="0" i="0" dirty="0">
+              <a:rPr sz="2200" b="0" i="0" dirty="0">
                 <a:solidFill>
                   <a:srgbClr val="5C4826"/>
                 </a:solidFill>
@@ -8547,8 +8555,8 @@
         </p:nvSpPr>
         <p:spPr>
           <a:xfrm>
-            <a:off x="5349240" y="2587752"/>
-            <a:ext cx="3474720" cy="384048"/>
+            <a:off x="5349240" y="2779776"/>
+            <a:ext cx="3474720" cy="658368"/>
           </a:xfrm>
           <a:prstGeom prst="rect">
             <a:avLst/>
@@ -8574,7 +8582,7 @@
           </a:fontRef>
         </p:style>
         <p:txBody>
-          <a:bodyPr wrap="square" lIns="27432" tIns="22860" rIns="27432" bIns="22860" rtlCol="0" anchor="ctr"/>
+          <a:bodyPr wrap="square" lIns="27432" tIns="0" rIns="27432" bIns="0" rtlCol="0" anchor="ctr"/>
           <a:lstStyle/>
           <a:p>
             <a:pPr algn="l"/>
@@ -8584,7 +8592,7 @@
                   <a:srgbClr val="555960"/>
                 </a:solidFill>
               </a:rPr>
-              <a:t>What do we depend on?</a:t>
+              <a:t>Which boundaries should we preserve or change?</a:t>
             </a:r>
           </a:p>
         </p:txBody>
@@ -8597,8 +8605,8 @@
         </p:nvSpPr>
         <p:spPr>
           <a:xfrm>
-            <a:off x="320040" y="3099816"/>
-            <a:ext cx="1783080" cy="502920"/>
+            <a:off x="320040" y="3511296"/>
+            <a:ext cx="1783080" cy="658368"/>
           </a:xfrm>
           <a:prstGeom prst="rect">
             <a:avLst/>
@@ -8633,7 +8641,7 @@
           <a:p>
             <a:pPr algn="ctr"/>
             <a:r>
-              <a:rPr sz="2000" b="1" i="0" dirty="0">
+              <a:rPr sz="2200" b="1" i="0" dirty="0">
                 <a:solidFill>
                   <a:srgbClr val="5C4826"/>
                 </a:solidFill>
@@ -8651,8 +8659,8 @@
         </p:nvSpPr>
         <p:spPr>
           <a:xfrm>
-            <a:off x="2240280" y="3099816"/>
-            <a:ext cx="2971800" cy="502920"/>
+            <a:off x="2240280" y="3511296"/>
+            <a:ext cx="2971800" cy="658368"/>
           </a:xfrm>
           <a:prstGeom prst="rect">
             <a:avLst/>
@@ -8687,7 +8695,7 @@
           <a:p>
             <a:pPr algn="ctr"/>
             <a:r>
-              <a:rPr sz="2000" b="0" i="0" dirty="0">
+              <a:rPr sz="2200" b="0" i="0" dirty="0">
                 <a:solidFill>
                   <a:srgbClr val="5C4826"/>
                 </a:solidFill>
@@ -8705,8 +8713,8 @@
         </p:nvSpPr>
         <p:spPr>
           <a:xfrm>
-            <a:off x="5349240" y="3163824"/>
-            <a:ext cx="3474720" cy="384048"/>
+            <a:off x="5349240" y="3511296"/>
+            <a:ext cx="3474720" cy="658368"/>
           </a:xfrm>
           <a:prstGeom prst="rect">
             <a:avLst/>
@@ -8732,7 +8740,7 @@
           </a:fontRef>
         </p:style>
         <p:txBody>
-          <a:bodyPr wrap="square" lIns="27432" tIns="22860" rIns="27432" bIns="22860" rtlCol="0" anchor="ctr"/>
+          <a:bodyPr wrap="square" lIns="27432" tIns="0" rIns="27432" bIns="0" rtlCol="0" anchor="ctr"/>
           <a:lstStyle/>
           <a:p>
             <a:pPr algn="l"/>
@@ -8742,7 +8750,7 @@
                   <a:srgbClr val="555960"/>
                 </a:solidFill>
               </a:rPr>
-              <a:t>Where is the bottleneck?</a:t>
+              <a:t>Which change will improve performance?</a:t>
             </a:r>
           </a:p>
         </p:txBody>
@@ -8755,8 +8763,8 @@
         </p:nvSpPr>
         <p:spPr>
           <a:xfrm>
-            <a:off x="320040" y="3675888"/>
-            <a:ext cx="1783080" cy="502920"/>
+            <a:off x="320040" y="4242816"/>
+            <a:ext cx="1783080" cy="658368"/>
           </a:xfrm>
           <a:prstGeom prst="rect">
             <a:avLst/>
@@ -8791,7 +8799,7 @@
           <a:p>
             <a:pPr algn="ctr"/>
             <a:r>
-              <a:rPr sz="2000" b="1" i="0" dirty="0">
+              <a:rPr sz="2200" b="1" i="0" dirty="0">
                 <a:solidFill>
                   <a:srgbClr val="5C4826"/>
                 </a:solidFill>
@@ -8809,8 +8817,8 @@
         </p:nvSpPr>
         <p:spPr>
           <a:xfrm>
-            <a:off x="2240280" y="3675888"/>
-            <a:ext cx="2971800" cy="502920"/>
+            <a:off x="2240280" y="4242816"/>
+            <a:ext cx="2971800" cy="658368"/>
           </a:xfrm>
           <a:prstGeom prst="rect">
             <a:avLst/>
@@ -8845,7 +8853,7 @@
           <a:p>
             <a:pPr algn="ctr"/>
             <a:r>
-              <a:rPr sz="2000" b="0" i="0" dirty="0">
+              <a:rPr sz="2200" b="0" i="0" dirty="0">
                 <a:solidFill>
                   <a:srgbClr val="5C4826"/>
                 </a:solidFill>
@@ -8863,8 +8871,8 @@
         </p:nvSpPr>
         <p:spPr>
           <a:xfrm>
-            <a:off x="5349240" y="3739896"/>
-            <a:ext cx="3474720" cy="384048"/>
+            <a:off x="5349240" y="4242816"/>
+            <a:ext cx="3474720" cy="658368"/>
           </a:xfrm>
           <a:prstGeom prst="rect">
             <a:avLst/>
@@ -8890,7 +8898,7 @@
           </a:fontRef>
         </p:style>
         <p:txBody>
-          <a:bodyPr wrap="square" lIns="27432" tIns="22860" rIns="27432" bIns="22860" rtlCol="0" anchor="ctr"/>
+          <a:bodyPr wrap="square" lIns="27432" tIns="0" rIns="27432" bIns="0" rtlCol="0" anchor="ctr"/>
           <a:lstStyle/>
           <a:p>
             <a:pPr algn="l"/>
@@ -8913,8 +8921,8 @@
         </p:nvSpPr>
         <p:spPr>
           <a:xfrm>
-            <a:off x="320040" y="4251960"/>
-            <a:ext cx="1783080" cy="502920"/>
+            <a:off x="320040" y="4974336"/>
+            <a:ext cx="1783080" cy="658368"/>
           </a:xfrm>
           <a:prstGeom prst="rect">
             <a:avLst/>
@@ -8949,7 +8957,7 @@
           <a:p>
             <a:pPr algn="ctr"/>
             <a:r>
-              <a:rPr sz="2000" b="1" i="0" dirty="0">
+              <a:rPr sz="2200" b="1" i="0" dirty="0">
                 <a:solidFill>
                   <a:srgbClr val="5C4826"/>
                 </a:solidFill>
@@ -8967,8 +8975,8 @@
         </p:nvSpPr>
         <p:spPr>
           <a:xfrm>
-            <a:off x="2240280" y="4251960"/>
-            <a:ext cx="2971800" cy="502920"/>
+            <a:off x="2240280" y="4974336"/>
+            <a:ext cx="2971800" cy="658368"/>
           </a:xfrm>
           <a:prstGeom prst="rect">
             <a:avLst/>
@@ -9003,7 +9011,7 @@
           <a:p>
             <a:pPr algn="ctr"/>
             <a:r>
-              <a:rPr sz="2000" b="0" i="0" dirty="0">
+              <a:rPr sz="2200" b="0" i="0" dirty="0">
                 <a:solidFill>
                   <a:srgbClr val="5C4826"/>
                 </a:solidFill>
@@ -9021,8 +9029,8 @@
         </p:nvSpPr>
         <p:spPr>
           <a:xfrm>
-            <a:off x="5349240" y="4315968"/>
-            <a:ext cx="3474720" cy="384048"/>
+            <a:off x="5349240" y="4974336"/>
+            <a:ext cx="3474720" cy="658368"/>
           </a:xfrm>
           <a:prstGeom prst="rect">
             <a:avLst/>
@@ -9048,7 +9056,7 @@
           </a:fontRef>
         </p:style>
         <p:txBody>
-          <a:bodyPr wrap="square" lIns="27432" tIns="22860" rIns="27432" bIns="22860" rtlCol="0" anchor="ctr"/>
+          <a:bodyPr wrap="square" lIns="27432" tIns="0" rIns="27432" bIns="0" rtlCol="0" anchor="ctr"/>
           <a:lstStyle/>
           <a:p>
             <a:pPr algn="l"/>
@@ -9071,7 +9079,7 @@
         </p:nvSpPr>
         <p:spPr>
           <a:xfrm>
-            <a:off x="365760" y="4873752"/>
+            <a:off x="365760" y="5760720"/>
             <a:ext cx="8412480" cy="365760"/>
           </a:xfrm>
           <a:prstGeom prst="rect">
@@ -9103,7 +9111,7 @@
           <a:p>
             <a:pPr algn="ctr"/>
             <a:r>
-              <a:rPr sz="2000" b="0" i="1" dirty="0">
+              <a:rPr sz="2200" b="0" i="1" dirty="0">
                 <a:solidFill>
                   <a:srgbClr val="5C4826"/>
                 </a:solidFill>

</xml_diff>

<commit_message>
deck 3-0 author review P1: slide 2 service boundary, slide 6 requires/provides closing question, slide 1 cover cleanup
Slide 2: 'no cloud deployment' -> 'no production deployment' (slide + notes);
explicit system boundary: Browser outside, arrow into an enclosing
RESERVATION SERVICE box containing HTTP API -> Reservation logic ->
In-memory reservations. Closing question band unchanged.
Slide 6: delete the right-hand explanatory prose and the next-lecture strip;
laptop slab widened; supplies column becomes paired requires <-> provides
annotations (CPU time/processor, memory/RAM, network access/network
interface, runtime dependencies/OS and libraries, temporary storage/
filesystem); slide now ends on a gold band: 'Where should this application
execute?'. Notes updated to match.
Slide 1: drop 'The Act III kickoff' subtitle; tighten title block; three-act
progression enlarged (24pt, heavier arrows) as the principal visual.

Co-Authored-By: Claude Opus 5 <noreply@anthropic.com>
</commit_message>
<xml_diff>
--- a/course/lectures/act-3-software-in-the-world/3-0-Act-III-Kickoff.pptx
+++ b/course/lectures/act-3-software-in-the-world/3-0-Act-III-Kickoff.pptx
@@ -1167,7 +1167,7 @@
           </a:p>
           <a:p>
             <a:r>
-              <a:t>STARTING ASSUMPTIONS, stated so later lectures can change them explicitly rather than silently: no persistent database, no authentication, no cloud deployment. When a later lecture adds one of these, it will say so — nothing about the example may be silently restated.</a:t>
+              <a:t>STARTING ASSUMPTIONS, stated so later lectures can change them explicitly rather than silently: no persistent database, no authentication, no production deployment. When a later lecture adds one of these, it will say so — nothing about the example may be silently restated.</a:t>
             </a:r>
           </a:p>
           <a:p>
@@ -1542,7 +1542,7 @@
           </a:p>
           <a:p>
             <a:r>
-              <a:t>SAY: the reservation service has been running somewhere all along — a developer's laptop, which quietly supplied CPU, memory, an operating system, a network, and storage. Nobody chose that environment; it was just there.</a:t>
+              <a:t>SAY: the reservation service has been running somewhere all along — a developer's laptop, which quietly supplied a processor, RAM, a network interface, an OS and libraries, and a filesystem, each matching something the application requires. Nobody chose that environment; it was just there.</a:t>
             </a:r>
           </a:p>
           <a:p>
@@ -1552,7 +1552,7 @@
           </a:p>
           <a:p>
             <a:r>
-              <a:t>HANDOFF (the bottom strip): leave the question open. The deployment lecture's first substantive slide answers it; do not start answering it here.</a:t>
+              <a:t>HANDOFF (the bottom band): end on the question, and leave it open. The deployment lecture's first substantive slide answers it; do not start answering it here.</a:t>
             </a:r>
           </a:p>
           <a:p>
@@ -5165,8 +5165,8 @@
         </p:nvSpPr>
         <p:spPr>
           <a:xfrm>
-            <a:off x="219456" y="1298448"/>
-            <a:ext cx="8695944" cy="2971800"/>
+            <a:off x="219456" y="1188720"/>
+            <a:ext cx="8695944" cy="2468880"/>
           </a:xfrm>
           <a:prstGeom prst="rect">
             <a:avLst/>
@@ -5207,21 +5207,6 @@
           <a:p>
             <a:pPr algn="ctr">
               <a:spcBef>
-                <a:spcPts val="1400"/>
-              </a:spcBef>
-            </a:pPr>
-            <a:r>
-              <a:rPr sz="2000" b="1" i="0" dirty="0">
-                <a:solidFill>
-                  <a:srgbClr val="000000"/>
-                </a:solidFill>
-              </a:rPr>
-              <a:t>The Act III kickoff</a:t>
-            </a:r>
-          </a:p>
-          <a:p>
-            <a:pPr algn="ctr">
-              <a:spcBef>
                 <a:spcPts val="1000"/>
               </a:spcBef>
             </a:pPr>
@@ -5244,8 +5229,8 @@
         </p:nvSpPr>
         <p:spPr>
           <a:xfrm>
-            <a:off x="274320" y="4434840"/>
-            <a:ext cx="2743200" cy="1188720"/>
+            <a:off x="274320" y="4069080"/>
+            <a:ext cx="2743200" cy="1417320"/>
           </a:xfrm>
           <a:prstGeom prst="rect">
             <a:avLst/>
@@ -5280,7 +5265,7 @@
           <a:p>
             <a:pPr algn="ctr"/>
             <a:r>
-              <a:rPr sz="2000" b="1" i="0" dirty="0">
+              <a:rPr sz="2400" b="1" i="0" dirty="0">
                 <a:solidFill>
                   <a:srgbClr val="5C4826"/>
                 </a:solidFill>
@@ -5295,7 +5280,7 @@
               </a:spcBef>
             </a:pPr>
             <a:r>
-              <a:rPr sz="2000" b="0" i="0" dirty="0">
+              <a:rPr sz="2400" b="0" i="0" dirty="0">
                 <a:solidFill>
                   <a:srgbClr val="5C4826"/>
                 </a:solidFill>
@@ -5313,8 +5298,8 @@
         </p:nvSpPr>
         <p:spPr>
           <a:xfrm>
-            <a:off x="3200400" y="4434840"/>
-            <a:ext cx="2743200" cy="1188720"/>
+            <a:off x="3200400" y="4069080"/>
+            <a:ext cx="2743200" cy="1417320"/>
           </a:xfrm>
           <a:prstGeom prst="rect">
             <a:avLst/>
@@ -5349,7 +5334,7 @@
           <a:p>
             <a:pPr algn="ctr"/>
             <a:r>
-              <a:rPr sz="2000" b="1" i="0" dirty="0">
+              <a:rPr sz="2400" b="1" i="0" dirty="0">
                 <a:solidFill>
                   <a:srgbClr val="5C4826"/>
                 </a:solidFill>
@@ -5364,7 +5349,7 @@
               </a:spcBef>
             </a:pPr>
             <a:r>
-              <a:rPr sz="2000" b="0" i="0" dirty="0">
+              <a:rPr sz="2400" b="0" i="0" dirty="0">
                 <a:solidFill>
                   <a:srgbClr val="5C4826"/>
                 </a:solidFill>
@@ -5382,8 +5367,8 @@
         </p:nvSpPr>
         <p:spPr>
           <a:xfrm>
-            <a:off x="6126480" y="4434840"/>
-            <a:ext cx="2743200" cy="1188720"/>
+            <a:off x="6126480" y="4069080"/>
+            <a:ext cx="2743200" cy="1417320"/>
           </a:xfrm>
           <a:prstGeom prst="rect">
             <a:avLst/>
@@ -5416,7 +5401,7 @@
           <a:p>
             <a:pPr algn="ctr"/>
             <a:r>
-              <a:rPr sz="2000" b="1" i="0" dirty="0">
+              <a:rPr sz="2400" b="1" i="0" dirty="0">
                 <a:solidFill>
                   <a:srgbClr val="FFFFFF"/>
                 </a:solidFill>
@@ -5431,7 +5416,7 @@
               </a:spcBef>
             </a:pPr>
             <a:r>
-              <a:rPr sz="2000" b="0" i="0" dirty="0">
+              <a:rPr sz="2400" b="0" i="0" dirty="0">
                 <a:solidFill>
                   <a:srgbClr val="FFFFFF"/>
                 </a:solidFill>
@@ -5449,13 +5434,13 @@
         </p:nvCxnSpPr>
         <p:spPr>
           <a:xfrm>
-            <a:off x="3054096" y="5029200"/>
-            <a:ext cx="109728" cy="0"/>
+            <a:off x="3035808" y="4777740"/>
+            <a:ext cx="146304" cy="0"/>
           </a:xfrm>
           <a:prstGeom prst="line">
             <a:avLst/>
           </a:prstGeom>
-          <a:ln w="19050">
+          <a:ln w="28575">
             <a:solidFill>
               <a:srgbClr val="8E6F3E"/>
             </a:solidFill>
@@ -5485,13 +5470,13 @@
         </p:nvCxnSpPr>
         <p:spPr>
           <a:xfrm>
-            <a:off x="5980176" y="5029200"/>
-            <a:ext cx="109728" cy="0"/>
+            <a:off x="5961888" y="4777740"/>
+            <a:ext cx="146304" cy="0"/>
           </a:xfrm>
           <a:prstGeom prst="line">
             <a:avLst/>
           </a:prstGeom>
-          <a:ln w="19050">
+          <a:ln w="28575">
             <a:solidFill>
               <a:srgbClr val="8E6F3E"/>
             </a:solidFill>
@@ -5583,6 +5568,35 @@
       </p:sp>
       <p:sp>
         <p:nvSpPr>
+          <p:cNvPr id="1101" name="ServiceBoundary"/>
+          <p:cNvSpPr/>
+          <p:nvPr/>
+        </p:nvSpPr>
+        <p:spPr>
+          <a:xfrm>
+            <a:off x="329184" y="1874519"/>
+            <a:ext cx="2816352" cy="3383280"/>
+          </a:xfrm>
+          <a:prstGeom prst="rect">
+            <a:avLst/>
+          </a:prstGeom>
+          <a:solidFill>
+            <a:srgbClr val="F5F1E8"/>
+          </a:solidFill>
+          <a:ln w="12700">
+            <a:solidFill>
+              <a:srgbClr val="C9B991"/>
+            </a:solidFill>
+          </a:ln>
+        </p:spPr>
+        <p:txBody>
+          <a:bodyPr wrap="square" rtlCol="0"/>
+          <a:lstStyle/>
+          <a:p/>
+        </p:txBody>
+      </p:sp>
+      <p:sp>
+        <p:nvSpPr>
           <p:cNvPr id="1002" name="Block"/>
           <p:cNvSpPr/>
           <p:nvPr/>
@@ -5590,7 +5604,7 @@
         <p:spPr>
           <a:xfrm>
             <a:off x="457200" y="1051560"/>
-            <a:ext cx="2560320" cy="685800"/>
+            <a:ext cx="2560320" cy="548640"/>
           </a:xfrm>
           <a:prstGeom prst="rect">
             <a:avLst/>
@@ -5635,14 +5649,49 @@
       </p:sp>
       <p:sp>
         <p:nvSpPr>
+          <p:cNvPr id="1102" name="ServiceLabel"/>
+          <p:cNvSpPr/>
+          <p:nvPr/>
+        </p:nvSpPr>
+        <p:spPr>
+          <a:xfrm>
+            <a:off x="420624" y="1938528"/>
+            <a:ext cx="2633472" cy="347472"/>
+          </a:xfrm>
+          <a:prstGeom prst="rect">
+            <a:avLst/>
+          </a:prstGeom>
+          <a:noFill/>
+          <a:ln>
+            <a:noFill/>
+          </a:ln>
+        </p:spPr>
+        <p:txBody>
+          <a:bodyPr wrap="square" lIns="27432" tIns="11430" rIns="27432" bIns="11430" rtlCol="0" anchor="ctr"/>
+          <a:lstStyle/>
+          <a:p>
+            <a:pPr algn="ctr"/>
+            <a:r>
+              <a:rPr sz="2000" b="1" i="0" dirty="0">
+                <a:solidFill>
+                  <a:srgbClr val="5C4826"/>
+                </a:solidFill>
+              </a:rPr>
+              <a:t>RESERVATION SERVICE</a:t>
+            </a:r>
+          </a:p>
+        </p:txBody>
+      </p:sp>
+      <p:sp>
+        <p:nvSpPr>
           <p:cNvPr id="1003" name="Block"/>
           <p:cNvSpPr/>
           <p:nvPr/>
         </p:nvSpPr>
         <p:spPr>
           <a:xfrm>
-            <a:off x="457200" y="1965960"/>
-            <a:ext cx="2560320" cy="685800"/>
+            <a:off x="557784" y="2395728"/>
+            <a:ext cx="2359152" cy="640080"/>
           </a:xfrm>
           <a:prstGeom prst="rect">
             <a:avLst/>
@@ -5693,8 +5742,8 @@
         </p:nvCxnSpPr>
         <p:spPr>
           <a:xfrm>
-            <a:off x="1737360" y="1737360"/>
-            <a:ext cx="0" cy="228600"/>
+            <a:off x="1737360" y="1600200"/>
+            <a:ext cx="0" cy="274320"/>
           </a:xfrm>
           <a:prstGeom prst="line">
             <a:avLst/>
@@ -5729,8 +5778,8 @@
         </p:nvSpPr>
         <p:spPr>
           <a:xfrm>
-            <a:off x="457200" y="2880360"/>
-            <a:ext cx="2560320" cy="685800"/>
+            <a:off x="557784" y="3236976"/>
+            <a:ext cx="2359152" cy="640080"/>
           </a:xfrm>
           <a:prstGeom prst="rect">
             <a:avLst/>
@@ -5781,8 +5830,8 @@
         </p:nvCxnSpPr>
         <p:spPr>
           <a:xfrm>
-            <a:off x="1737360" y="2651760"/>
-            <a:ext cx="0" cy="228600"/>
+            <a:off x="1737360" y="3035808"/>
+            <a:ext cx="0" cy="201168"/>
           </a:xfrm>
           <a:prstGeom prst="line">
             <a:avLst/>
@@ -5817,8 +5866,8 @@
         </p:nvSpPr>
         <p:spPr>
           <a:xfrm>
-            <a:off x="457200" y="3794760"/>
-            <a:ext cx="2560320" cy="685800"/>
+            <a:off x="557784" y="4078224"/>
+            <a:ext cx="2359152" cy="868680"/>
           </a:xfrm>
           <a:prstGeom prst="rect">
             <a:avLst/>
@@ -5869,8 +5918,8 @@
         </p:nvCxnSpPr>
         <p:spPr>
           <a:xfrm>
-            <a:off x="1737360" y="3566160"/>
-            <a:ext cx="0" cy="228600"/>
+            <a:off x="1737360" y="3877056"/>
+            <a:ext cx="0" cy="201168"/>
           </a:xfrm>
           <a:prstGeom prst="line">
             <a:avLst/>
@@ -6110,7 +6159,7 @@
                   <a:srgbClr val="5C4826"/>
                 </a:solidFill>
               </a:rPr>
-              <a:t>no cloud deployment</a:t>
+              <a:t>no production deployment</a:t>
             </a:r>
           </a:p>
         </p:txBody>
@@ -9198,7 +9247,7 @@
         <p:spPr>
           <a:xfrm>
             <a:off x="457200" y="1188720"/>
-            <a:ext cx="5669280" cy="4069080"/>
+            <a:ext cx="8229600" cy="4069080"/>
           </a:xfrm>
           <a:prstGeom prst="rect">
             <a:avLst/>
@@ -9607,8 +9656,8 @@
         </p:nvSpPr>
         <p:spPr>
           <a:xfrm>
-            <a:off x="3474720" y="1417320"/>
-            <a:ext cx="2377440" cy="365760"/>
+            <a:off x="3154680" y="1417320"/>
+            <a:ext cx="2880360" cy="365760"/>
           </a:xfrm>
           <a:prstGeom prst="rect">
             <a:avLst/>
@@ -9644,7 +9693,7 @@
                   <a:srgbClr val="555960"/>
                 </a:solidFill>
               </a:rPr>
-              <a:t>what it supplies</a:t>
+              <a:t>the application requires</a:t>
             </a:r>
           </a:p>
         </p:txBody>
@@ -9657,8 +9706,8 @@
         </p:nvSpPr>
         <p:spPr>
           <a:xfrm>
-            <a:off x="3474720" y="2011680"/>
-            <a:ext cx="2377440" cy="475488"/>
+            <a:off x="3429000" y="2011680"/>
+            <a:ext cx="2331720" cy="475488"/>
           </a:xfrm>
           <a:prstGeom prst="rect">
             <a:avLst/>
@@ -9698,7 +9747,7 @@
                   <a:srgbClr val="5C4826"/>
                 </a:solidFill>
               </a:rPr>
-              <a:t>CPU</a:t>
+              <a:t>CPU time</a:t>
             </a:r>
           </a:p>
         </p:txBody>
@@ -9711,8 +9760,8 @@
         </p:nvSpPr>
         <p:spPr>
           <a:xfrm>
-            <a:off x="3474720" y="2633472"/>
-            <a:ext cx="2377440" cy="475488"/>
+            <a:off x="3429000" y="2633472"/>
+            <a:ext cx="2331720" cy="475488"/>
           </a:xfrm>
           <a:prstGeom prst="rect">
             <a:avLst/>
@@ -9765,8 +9814,8 @@
         </p:nvSpPr>
         <p:spPr>
           <a:xfrm>
-            <a:off x="3474720" y="3255264"/>
-            <a:ext cx="2377440" cy="475488"/>
+            <a:off x="3429000" y="3255264"/>
+            <a:ext cx="2331720" cy="475488"/>
           </a:xfrm>
           <a:prstGeom prst="rect">
             <a:avLst/>
@@ -9806,7 +9855,7 @@
                   <a:srgbClr val="5C4826"/>
                 </a:solidFill>
               </a:rPr>
-              <a:t>operating system</a:t>
+              <a:t>network access</a:t>
             </a:r>
           </a:p>
         </p:txBody>
@@ -9819,8 +9868,8 @@
         </p:nvSpPr>
         <p:spPr>
           <a:xfrm>
-            <a:off x="3474720" y="3877056"/>
-            <a:ext cx="2377440" cy="475488"/>
+            <a:off x="3429000" y="3877056"/>
+            <a:ext cx="2331720" cy="475488"/>
           </a:xfrm>
           <a:prstGeom prst="rect">
             <a:avLst/>
@@ -9860,7 +9909,7 @@
                   <a:srgbClr val="5C4826"/>
                 </a:solidFill>
               </a:rPr>
-              <a:t>network</a:t>
+              <a:t>runtime dependencies</a:t>
             </a:r>
           </a:p>
         </p:txBody>
@@ -9873,8 +9922,8 @@
         </p:nvSpPr>
         <p:spPr>
           <a:xfrm>
-            <a:off x="3474720" y="4498848"/>
-            <a:ext cx="2377440" cy="475488"/>
+            <a:off x="3429000" y="4498848"/>
+            <a:ext cx="2331720" cy="475488"/>
           </a:xfrm>
           <a:prstGeom prst="rect">
             <a:avLst/>
@@ -9914,21 +9963,21 @@
                   <a:srgbClr val="5C4826"/>
                 </a:solidFill>
               </a:rPr>
-              <a:t>storage</a:t>
-            </a:r>
-          </a:p>
-        </p:txBody>
-      </p:sp>
-      <p:sp>
-        <p:nvSpPr>
-          <p:cNvPr id="1017" name="Label"/>
+              <a:t>temporary storage</a:t>
+            </a:r>
+          </a:p>
+        </p:txBody>
+      </p:sp>
+      <p:sp>
+        <p:nvSpPr>
+          <p:cNvPr id="1106" name="ProvidesLabel"/>
           <p:cNvSpPr/>
           <p:nvPr/>
         </p:nvSpPr>
         <p:spPr>
           <a:xfrm>
-            <a:off x="6400800" y="1737360"/>
-            <a:ext cx="2468880" cy="2468880"/>
+            <a:off x="6144768" y="1417320"/>
+            <a:ext cx="2267712" cy="365760"/>
           </a:xfrm>
           <a:prstGeom prst="rect">
             <a:avLst/>
@@ -9957,50 +10006,39 @@
           <a:bodyPr wrap="square" lIns="27432" tIns="22860" rIns="27432" bIns="22860" rtlCol="0" anchor="ctr"/>
           <a:lstStyle/>
           <a:p>
-            <a:pPr algn="l"/>
-            <a:r>
-              <a:rPr sz="2000" b="0" i="0" dirty="0">
+            <a:pPr algn="ctr"/>
+            <a:r>
+              <a:rPr sz="2000" b="0" i="1" dirty="0">
                 <a:solidFill>
                   <a:srgbClr val="555960"/>
                 </a:solidFill>
               </a:rPr>
-              <a:t>So far, all of this was implicit.</a:t>
-            </a:r>
-          </a:p>
-          <a:p>
-            <a:pPr algn="l">
-              <a:spcBef>
-                <a:spcPts val="800"/>
-              </a:spcBef>
-            </a:pPr>
-            <a:r>
-              <a:rPr sz="2000" b="0" i="0" dirty="0">
-                <a:solidFill>
-                  <a:srgbClr val="555960"/>
-                </a:solidFill>
-              </a:rPr>
-              <a:t>Today we make it explicit, and we choose it.</a:t>
-            </a:r>
-          </a:p>
-        </p:txBody>
-      </p:sp>
-      <p:sp>
-        <p:nvSpPr>
-          <p:cNvPr id="1018" name="HandoffStrip"/>
+              <a:t>the laptop provides</a:t>
+            </a:r>
+          </a:p>
+        </p:txBody>
+      </p:sp>
+      <p:sp>
+        <p:nvSpPr>
+          <p:cNvPr id="1101" name="Card"/>
           <p:cNvSpPr/>
           <p:nvPr/>
         </p:nvSpPr>
         <p:spPr>
           <a:xfrm>
-            <a:off x="457200" y="5440680"/>
-            <a:ext cx="8229600" cy="731520"/>
+            <a:off x="6144768" y="2011680"/>
+            <a:ext cx="2267712" cy="475488"/>
           </a:xfrm>
           <a:prstGeom prst="rect">
             <a:avLst/>
           </a:prstGeom>
-          <a:noFill/>
-          <a:ln>
-            <a:noFill/>
+          <a:solidFill>
+            <a:srgbClr val="FFFFFF"/>
+          </a:solidFill>
+          <a:ln w="12700">
+            <a:solidFill>
+              <a:srgbClr val="C9B991"/>
+            </a:solidFill>
           </a:ln>
           <a:effectLst/>
         </p:spPr>
@@ -10022,14 +10060,467 @@
           <a:bodyPr wrap="square" lIns="27432" tIns="22860" rIns="27432" bIns="22860" rtlCol="0" anchor="ctr"/>
           <a:lstStyle/>
           <a:p>
-            <a:pPr algn="l"/>
-            <a:r>
-              <a:rPr sz="2000" b="0" i="1" dirty="0">
+            <a:pPr algn="ctr"/>
+            <a:r>
+              <a:rPr sz="2000" b="0" i="0" dirty="0">
                 <a:solidFill>
-                  <a:srgbClr val="555960"/>
+                  <a:srgbClr val="5C4826"/>
                 </a:solidFill>
               </a:rPr>
-              <a:t>Next: the Compute Environments &amp; Deployment lecture takes up this question</a:t>
+              <a:t>processor</a:t>
+            </a:r>
+          </a:p>
+        </p:txBody>
+      </p:sp>
+      <p:cxnSp>
+        <p:nvCxnSpPr>
+          <p:cNvPr id="1107" name="PairLink"/>
+          <p:cNvCxnSpPr/>
+          <p:nvPr/>
+        </p:nvCxnSpPr>
+        <p:spPr>
+          <a:xfrm>
+            <a:off x="5797296" y="2249424"/>
+            <a:ext cx="310896" cy="0"/>
+          </a:xfrm>
+          <a:prstGeom prst="line">
+            <a:avLst/>
+          </a:prstGeom>
+          <a:ln w="19050">
+            <a:solidFill>
+              <a:srgbClr val="8E6F3E"/>
+            </a:solidFill>
+            <a:headEnd type="triangle"/>
+            <a:tailEnd type="triangle"/>
+          </a:ln>
+        </p:spPr>
+        <p:style>
+          <a:lnRef idx="2">
+            <a:schemeClr val="accent1"/>
+          </a:lnRef>
+          <a:fillRef idx="0">
+            <a:schemeClr val="accent1"/>
+          </a:fillRef>
+          <a:effectRef idx="1">
+            <a:schemeClr val="accent1"/>
+          </a:effectRef>
+          <a:fontRef idx="minor">
+            <a:schemeClr val="tx1"/>
+          </a:fontRef>
+        </p:style>
+      </p:cxnSp>
+      <p:sp>
+        <p:nvSpPr>
+          <p:cNvPr id="1102" name="Card"/>
+          <p:cNvSpPr/>
+          <p:nvPr/>
+        </p:nvSpPr>
+        <p:spPr>
+          <a:xfrm>
+            <a:off x="6144768" y="2633472"/>
+            <a:ext cx="2267712" cy="475488"/>
+          </a:xfrm>
+          <a:prstGeom prst="rect">
+            <a:avLst/>
+          </a:prstGeom>
+          <a:solidFill>
+            <a:srgbClr val="FFFFFF"/>
+          </a:solidFill>
+          <a:ln w="12700">
+            <a:solidFill>
+              <a:srgbClr val="C9B991"/>
+            </a:solidFill>
+          </a:ln>
+          <a:effectLst/>
+        </p:spPr>
+        <p:style>
+          <a:lnRef idx="1">
+            <a:schemeClr val="accent1"/>
+          </a:lnRef>
+          <a:fillRef idx="3">
+            <a:schemeClr val="accent1"/>
+          </a:fillRef>
+          <a:effectRef idx="2">
+            <a:schemeClr val="accent1"/>
+          </a:effectRef>
+          <a:fontRef idx="minor">
+            <a:schemeClr val="lt1"/>
+          </a:fontRef>
+        </p:style>
+        <p:txBody>
+          <a:bodyPr wrap="square" lIns="27432" tIns="22860" rIns="27432" bIns="22860" rtlCol="0" anchor="ctr"/>
+          <a:lstStyle/>
+          <a:p>
+            <a:pPr algn="ctr"/>
+            <a:r>
+              <a:rPr sz="2000" b="0" i="0" dirty="0">
+                <a:solidFill>
+                  <a:srgbClr val="5C4826"/>
+                </a:solidFill>
+              </a:rPr>
+              <a:t>RAM</a:t>
+            </a:r>
+          </a:p>
+        </p:txBody>
+      </p:sp>
+      <p:cxnSp>
+        <p:nvCxnSpPr>
+          <p:cNvPr id="1108" name="PairLink"/>
+          <p:cNvCxnSpPr/>
+          <p:nvPr/>
+        </p:nvCxnSpPr>
+        <p:spPr>
+          <a:xfrm>
+            <a:off x="5797296" y="2871216"/>
+            <a:ext cx="310896" cy="0"/>
+          </a:xfrm>
+          <a:prstGeom prst="line">
+            <a:avLst/>
+          </a:prstGeom>
+          <a:ln w="19050">
+            <a:solidFill>
+              <a:srgbClr val="8E6F3E"/>
+            </a:solidFill>
+            <a:headEnd type="triangle"/>
+            <a:tailEnd type="triangle"/>
+          </a:ln>
+        </p:spPr>
+        <p:style>
+          <a:lnRef idx="2">
+            <a:schemeClr val="accent1"/>
+          </a:lnRef>
+          <a:fillRef idx="0">
+            <a:schemeClr val="accent1"/>
+          </a:fillRef>
+          <a:effectRef idx="1">
+            <a:schemeClr val="accent1"/>
+          </a:effectRef>
+          <a:fontRef idx="minor">
+            <a:schemeClr val="tx1"/>
+          </a:fontRef>
+        </p:style>
+      </p:cxnSp>
+      <p:sp>
+        <p:nvSpPr>
+          <p:cNvPr id="1103" name="Card"/>
+          <p:cNvSpPr/>
+          <p:nvPr/>
+        </p:nvSpPr>
+        <p:spPr>
+          <a:xfrm>
+            <a:off x="6144768" y="3255264"/>
+            <a:ext cx="2267712" cy="475488"/>
+          </a:xfrm>
+          <a:prstGeom prst="rect">
+            <a:avLst/>
+          </a:prstGeom>
+          <a:solidFill>
+            <a:srgbClr val="FFFFFF"/>
+          </a:solidFill>
+          <a:ln w="12700">
+            <a:solidFill>
+              <a:srgbClr val="C9B991"/>
+            </a:solidFill>
+          </a:ln>
+          <a:effectLst/>
+        </p:spPr>
+        <p:style>
+          <a:lnRef idx="1">
+            <a:schemeClr val="accent1"/>
+          </a:lnRef>
+          <a:fillRef idx="3">
+            <a:schemeClr val="accent1"/>
+          </a:fillRef>
+          <a:effectRef idx="2">
+            <a:schemeClr val="accent1"/>
+          </a:effectRef>
+          <a:fontRef idx="minor">
+            <a:schemeClr val="lt1"/>
+          </a:fontRef>
+        </p:style>
+        <p:txBody>
+          <a:bodyPr wrap="square" lIns="27432" tIns="22860" rIns="27432" bIns="22860" rtlCol="0" anchor="ctr"/>
+          <a:lstStyle/>
+          <a:p>
+            <a:pPr algn="ctr"/>
+            <a:r>
+              <a:rPr sz="2000" b="0" i="0" dirty="0">
+                <a:solidFill>
+                  <a:srgbClr val="5C4826"/>
+                </a:solidFill>
+              </a:rPr>
+              <a:t>network interface</a:t>
+            </a:r>
+          </a:p>
+        </p:txBody>
+      </p:sp>
+      <p:cxnSp>
+        <p:nvCxnSpPr>
+          <p:cNvPr id="1109" name="PairLink"/>
+          <p:cNvCxnSpPr/>
+          <p:nvPr/>
+        </p:nvCxnSpPr>
+        <p:spPr>
+          <a:xfrm>
+            <a:off x="5797296" y="3493008"/>
+            <a:ext cx="310896" cy="0"/>
+          </a:xfrm>
+          <a:prstGeom prst="line">
+            <a:avLst/>
+          </a:prstGeom>
+          <a:ln w="19050">
+            <a:solidFill>
+              <a:srgbClr val="8E6F3E"/>
+            </a:solidFill>
+            <a:headEnd type="triangle"/>
+            <a:tailEnd type="triangle"/>
+          </a:ln>
+        </p:spPr>
+        <p:style>
+          <a:lnRef idx="2">
+            <a:schemeClr val="accent1"/>
+          </a:lnRef>
+          <a:fillRef idx="0">
+            <a:schemeClr val="accent1"/>
+          </a:fillRef>
+          <a:effectRef idx="1">
+            <a:schemeClr val="accent1"/>
+          </a:effectRef>
+          <a:fontRef idx="minor">
+            <a:schemeClr val="tx1"/>
+          </a:fontRef>
+        </p:style>
+      </p:cxnSp>
+      <p:sp>
+        <p:nvSpPr>
+          <p:cNvPr id="1104" name="Card"/>
+          <p:cNvSpPr/>
+          <p:nvPr/>
+        </p:nvSpPr>
+        <p:spPr>
+          <a:xfrm>
+            <a:off x="6144768" y="3877056"/>
+            <a:ext cx="2267712" cy="475488"/>
+          </a:xfrm>
+          <a:prstGeom prst="rect">
+            <a:avLst/>
+          </a:prstGeom>
+          <a:solidFill>
+            <a:srgbClr val="FFFFFF"/>
+          </a:solidFill>
+          <a:ln w="12700">
+            <a:solidFill>
+              <a:srgbClr val="C9B991"/>
+            </a:solidFill>
+          </a:ln>
+          <a:effectLst/>
+        </p:spPr>
+        <p:style>
+          <a:lnRef idx="1">
+            <a:schemeClr val="accent1"/>
+          </a:lnRef>
+          <a:fillRef idx="3">
+            <a:schemeClr val="accent1"/>
+          </a:fillRef>
+          <a:effectRef idx="2">
+            <a:schemeClr val="accent1"/>
+          </a:effectRef>
+          <a:fontRef idx="minor">
+            <a:schemeClr val="lt1"/>
+          </a:fontRef>
+        </p:style>
+        <p:txBody>
+          <a:bodyPr wrap="square" lIns="27432" tIns="22860" rIns="27432" bIns="22860" rtlCol="0" anchor="ctr"/>
+          <a:lstStyle/>
+          <a:p>
+            <a:pPr algn="ctr"/>
+            <a:r>
+              <a:rPr sz="2000" b="0" i="0" dirty="0">
+                <a:solidFill>
+                  <a:srgbClr val="5C4826"/>
+                </a:solidFill>
+              </a:rPr>
+              <a:t>OS and libraries</a:t>
+            </a:r>
+          </a:p>
+        </p:txBody>
+      </p:sp>
+      <p:cxnSp>
+        <p:nvCxnSpPr>
+          <p:cNvPr id="1110" name="PairLink"/>
+          <p:cNvCxnSpPr/>
+          <p:nvPr/>
+        </p:nvCxnSpPr>
+        <p:spPr>
+          <a:xfrm>
+            <a:off x="5797296" y="4114800"/>
+            <a:ext cx="310896" cy="0"/>
+          </a:xfrm>
+          <a:prstGeom prst="line">
+            <a:avLst/>
+          </a:prstGeom>
+          <a:ln w="19050">
+            <a:solidFill>
+              <a:srgbClr val="8E6F3E"/>
+            </a:solidFill>
+            <a:headEnd type="triangle"/>
+            <a:tailEnd type="triangle"/>
+          </a:ln>
+        </p:spPr>
+        <p:style>
+          <a:lnRef idx="2">
+            <a:schemeClr val="accent1"/>
+          </a:lnRef>
+          <a:fillRef idx="0">
+            <a:schemeClr val="accent1"/>
+          </a:fillRef>
+          <a:effectRef idx="1">
+            <a:schemeClr val="accent1"/>
+          </a:effectRef>
+          <a:fontRef idx="minor">
+            <a:schemeClr val="tx1"/>
+          </a:fontRef>
+        </p:style>
+      </p:cxnSp>
+      <p:sp>
+        <p:nvSpPr>
+          <p:cNvPr id="1105" name="Card"/>
+          <p:cNvSpPr/>
+          <p:nvPr/>
+        </p:nvSpPr>
+        <p:spPr>
+          <a:xfrm>
+            <a:off x="6144768" y="4498848"/>
+            <a:ext cx="2267712" cy="475488"/>
+          </a:xfrm>
+          <a:prstGeom prst="rect">
+            <a:avLst/>
+          </a:prstGeom>
+          <a:solidFill>
+            <a:srgbClr val="FFFFFF"/>
+          </a:solidFill>
+          <a:ln w="12700">
+            <a:solidFill>
+              <a:srgbClr val="C9B991"/>
+            </a:solidFill>
+          </a:ln>
+          <a:effectLst/>
+        </p:spPr>
+        <p:style>
+          <a:lnRef idx="1">
+            <a:schemeClr val="accent1"/>
+          </a:lnRef>
+          <a:fillRef idx="3">
+            <a:schemeClr val="accent1"/>
+          </a:fillRef>
+          <a:effectRef idx="2">
+            <a:schemeClr val="accent1"/>
+          </a:effectRef>
+          <a:fontRef idx="minor">
+            <a:schemeClr val="lt1"/>
+          </a:fontRef>
+        </p:style>
+        <p:txBody>
+          <a:bodyPr wrap="square" lIns="27432" tIns="22860" rIns="27432" bIns="22860" rtlCol="0" anchor="ctr"/>
+          <a:lstStyle/>
+          <a:p>
+            <a:pPr algn="ctr"/>
+            <a:r>
+              <a:rPr sz="2000" b="0" i="0" dirty="0">
+                <a:solidFill>
+                  <a:srgbClr val="5C4826"/>
+                </a:solidFill>
+              </a:rPr>
+              <a:t>filesystem</a:t>
+            </a:r>
+          </a:p>
+        </p:txBody>
+      </p:sp>
+      <p:cxnSp>
+        <p:nvCxnSpPr>
+          <p:cNvPr id="1111" name="PairLink"/>
+          <p:cNvCxnSpPr/>
+          <p:nvPr/>
+        </p:nvCxnSpPr>
+        <p:spPr>
+          <a:xfrm>
+            <a:off x="5797296" y="4736592"/>
+            <a:ext cx="310896" cy="0"/>
+          </a:xfrm>
+          <a:prstGeom prst="line">
+            <a:avLst/>
+          </a:prstGeom>
+          <a:ln w="19050">
+            <a:solidFill>
+              <a:srgbClr val="8E6F3E"/>
+            </a:solidFill>
+            <a:headEnd type="triangle"/>
+            <a:tailEnd type="triangle"/>
+          </a:ln>
+        </p:spPr>
+        <p:style>
+          <a:lnRef idx="2">
+            <a:schemeClr val="accent1"/>
+          </a:lnRef>
+          <a:fillRef idx="0">
+            <a:schemeClr val="accent1"/>
+          </a:fillRef>
+          <a:effectRef idx="1">
+            <a:schemeClr val="accent1"/>
+          </a:effectRef>
+          <a:fontRef idx="minor">
+            <a:schemeClr val="tx1"/>
+          </a:fontRef>
+        </p:style>
+      </p:cxnSp>
+      <p:sp>
+        <p:nvSpPr>
+          <p:cNvPr id="1112" name="FooterBand"/>
+          <p:cNvSpPr/>
+          <p:nvPr/>
+        </p:nvSpPr>
+        <p:spPr>
+          <a:xfrm>
+            <a:off x="274320" y="5512918"/>
+            <a:ext cx="8595360" cy="905256"/>
+          </a:xfrm>
+          <a:prstGeom prst="rect">
+            <a:avLst/>
+          </a:prstGeom>
+          <a:solidFill>
+            <a:srgbClr val="8E6F3E"/>
+          </a:solidFill>
+          <a:ln>
+            <a:noFill/>
+          </a:ln>
+          <a:effectLst/>
+        </p:spPr>
+        <p:style>
+          <a:lnRef idx="1">
+            <a:schemeClr val="accent1"/>
+          </a:lnRef>
+          <a:fillRef idx="3">
+            <a:schemeClr val="accent1"/>
+          </a:fillRef>
+          <a:effectRef idx="2">
+            <a:schemeClr val="accent1"/>
+          </a:effectRef>
+          <a:fontRef idx="minor">
+            <a:schemeClr val="lt1"/>
+          </a:fontRef>
+        </p:style>
+        <p:txBody>
+          <a:bodyPr wrap="square" lIns="27432" tIns="22860" rIns="27432" bIns="22860" rtlCol="0" anchor="ctr"/>
+          <a:lstStyle/>
+          <a:p>
+            <a:pPr algn="ctr"/>
+            <a:r>
+              <a:rPr sz="2000" b="1" i="0" dirty="0">
+                <a:solidFill>
+                  <a:srgbClr val="FFFFFF"/>
+                </a:solidFill>
+              </a:rPr>
+              <a:t>Where should this application execute?</a:t>
             </a:r>
           </a:p>
         </p:txBody>

</xml_diff>

<commit_message>
deck 3-0 author review P2: slide 3 numbered outline + qualification; type raised where space permits
Slide 3: bottom line is now exactly 'Teaching order, not development order.
These concerns interact throughout the system's life.'; the interaction
example moved into speaker notes; directional arrows and row-wrap segments
removed in favor of numbered topic blocks (1-6 badges); block labels 22pt.
Typography: raised 20pt labels to 22-24pt where the space genuinely permits
(slide 1 question + act cards, slide 2 diagram/stack/cards/footer, slide 3
blocks + qualification, slide 4 flow boxes + alignment captions, slide 5
headers/topic/model cells, slide 6 stack/headers/footer). Labels whose boxes
wrap at 22pt stay at the 20pt floor (slide 2 service label + capability list,
slide 4 revision labels, slide 5 judgment column, slide 6 pair cards).

Co-Authored-By: Claude Opus 5 <noreply@anthropic.com>
</commit_message>
<xml_diff>
--- a/course/lectures/act-3-software-in-the-world/3-0-Act-III-Kickoff.pptx
+++ b/course/lectures/act-3-software-in-the-world/3-0-Act-III-Kickoff.pptx
@@ -1267,7 +1267,7 @@
           </a:p>
           <a:p>
             <a:r>
-              <a:t>THE ANTI-LESSON (the italic line — the author added it deliberately): this is the order we TEACH, not the order these concerns ARRIVE. Security shapes architecture from day one; operations shape how you deploy; performance shapes how you manage data. If students leave believing security and operations are afterthoughts that come 'later', this slide has failed.</a:t>
+              <a:t>THE ANTI-LESSON (the bottom line): this is the order we TEACH, not the order these concerns ARRIVE; they interact throughout the system's life. EXAMPLE, moved off the slide: security shapes architecture from day one; operations shape how you deploy; performance shapes how you manage data. If students leave believing security and operations are afterthoughts that come 'later', this slide has failed.</a:t>
             </a:r>
           </a:p>
           <a:p>
@@ -5196,7 +5196,7 @@
               </a:spcBef>
             </a:pPr>
             <a:r>
-              <a:rPr sz="2000" b="0" i="1" dirty="0">
+              <a:rPr sz="2200" b="0" i="1" dirty="0">
                 <a:solidFill>
                   <a:srgbClr val="000000"/>
                 </a:solidFill>
@@ -5637,7 +5637,7 @@
           <a:p>
             <a:pPr algn="ctr"/>
             <a:r>
-              <a:rPr sz="2000" b="1" i="0" dirty="0">
+              <a:rPr sz="2200" b="1" i="0" dirty="0">
                 <a:solidFill>
                   <a:srgbClr val="FFFFFF"/>
                 </a:solidFill>
@@ -5690,8 +5690,8 @@
         </p:nvSpPr>
         <p:spPr>
           <a:xfrm>
-            <a:off x="557784" y="2395728"/>
-            <a:ext cx="2359152" cy="640080"/>
+            <a:off x="457200" y="2395728"/>
+            <a:ext cx="2560320" cy="640080"/>
           </a:xfrm>
           <a:prstGeom prst="rect">
             <a:avLst/>
@@ -5724,7 +5724,7 @@
           <a:p>
             <a:pPr algn="ctr"/>
             <a:r>
-              <a:rPr sz="2000" b="1" i="0" dirty="0">
+              <a:rPr sz="2200" b="1" i="0" dirty="0">
                 <a:solidFill>
                   <a:srgbClr val="FFFFFF"/>
                 </a:solidFill>
@@ -5778,8 +5778,8 @@
         </p:nvSpPr>
         <p:spPr>
           <a:xfrm>
-            <a:off x="557784" y="3236976"/>
-            <a:ext cx="2359152" cy="640080"/>
+            <a:off x="457200" y="3236976"/>
+            <a:ext cx="2560320" cy="640080"/>
           </a:xfrm>
           <a:prstGeom prst="rect">
             <a:avLst/>
@@ -5812,7 +5812,7 @@
           <a:p>
             <a:pPr algn="ctr"/>
             <a:r>
-              <a:rPr sz="2000" b="1" i="0" dirty="0">
+              <a:rPr sz="2200" b="1" i="0" dirty="0">
                 <a:solidFill>
                   <a:srgbClr val="FFFFFF"/>
                 </a:solidFill>
@@ -5866,8 +5866,8 @@
         </p:nvSpPr>
         <p:spPr>
           <a:xfrm>
-            <a:off x="557784" y="4078224"/>
-            <a:ext cx="2359152" cy="868680"/>
+            <a:off x="457200" y="4078224"/>
+            <a:ext cx="2560320" cy="868680"/>
           </a:xfrm>
           <a:prstGeom prst="rect">
             <a:avLst/>
@@ -5900,7 +5900,7 @@
           <a:p>
             <a:pPr algn="ctr"/>
             <a:r>
-              <a:rPr sz="2000" b="1" i="0" dirty="0">
+              <a:rPr sz="2200" b="1" i="0" dirty="0">
                 <a:solidFill>
                   <a:srgbClr val="FFFFFF"/>
                 </a:solidFill>
@@ -5986,7 +5986,7 @@
           <a:p>
             <a:pPr algn="l"/>
             <a:r>
-              <a:rPr sz="2000" b="1" i="0" dirty="0">
+              <a:rPr sz="2200" b="1" i="0" dirty="0">
                 <a:solidFill>
                   <a:srgbClr val="5C4826"/>
                 </a:solidFill>
@@ -6040,7 +6040,7 @@
           <a:p>
             <a:pPr algn="ctr"/>
             <a:r>
-              <a:rPr sz="2000" b="1" i="0" dirty="0">
+              <a:rPr sz="2200" b="1" i="0" dirty="0">
                 <a:solidFill>
                   <a:srgbClr val="5C4826"/>
                 </a:solidFill>
@@ -6109,7 +6109,7 @@
           <a:p>
             <a:pPr algn="ctr"/>
             <a:r>
-              <a:rPr sz="2000" b="1" i="0" dirty="0">
+              <a:rPr sz="2200" b="1" i="0" dirty="0">
                 <a:solidFill>
                   <a:srgbClr val="5C4826"/>
                 </a:solidFill>
@@ -6124,7 +6124,7 @@
               </a:spcBef>
             </a:pPr>
             <a:r>
-              <a:rPr sz="2000" b="0" i="0" dirty="0">
+              <a:rPr sz="2200" b="0" i="0" dirty="0">
                 <a:solidFill>
                   <a:srgbClr val="5C4826"/>
                 </a:solidFill>
@@ -6139,7 +6139,7 @@
               </a:spcBef>
             </a:pPr>
             <a:r>
-              <a:rPr sz="2000" b="0" i="0" dirty="0">
+              <a:rPr sz="2200" b="0" i="0" dirty="0">
                 <a:solidFill>
                   <a:srgbClr val="5C4826"/>
                 </a:solidFill>
@@ -6154,7 +6154,7 @@
               </a:spcBef>
             </a:pPr>
             <a:r>
-              <a:rPr sz="2000" b="0" i="0" dirty="0">
+              <a:rPr sz="2200" b="0" i="0" dirty="0">
                 <a:solidFill>
                   <a:srgbClr val="5C4826"/>
                 </a:solidFill>
@@ -6206,7 +6206,7 @@
           <a:p>
             <a:pPr algn="ctr"/>
             <a:r>
-              <a:rPr sz="2000" b="1" i="0" dirty="0">
+              <a:rPr sz="2200" b="1" i="0" dirty="0">
                 <a:solidFill>
                   <a:srgbClr val="FFFFFF"/>
                 </a:solidFill>
@@ -6221,7 +6221,7 @@
               </a:spcBef>
             </a:pPr>
             <a:r>
-              <a:rPr sz="2000" b="1" i="0" dirty="0">
+              <a:rPr sz="2200" b="1" i="0" dirty="0">
                 <a:solidFill>
                   <a:srgbClr val="FFFFFF"/>
                 </a:solidFill>
@@ -6341,7 +6341,7 @@
           <a:p>
             <a:pPr algn="ctr"/>
             <a:r>
-              <a:rPr sz="2000" b="1" i="0" dirty="0">
+              <a:rPr sz="2200" b="1" i="0" dirty="0">
                 <a:solidFill>
                   <a:srgbClr val="FFFFFF"/>
                 </a:solidFill>
@@ -6395,7 +6395,7 @@
           <a:p>
             <a:pPr algn="ctr"/>
             <a:r>
-              <a:rPr sz="2000" b="1" i="0" dirty="0">
+              <a:rPr sz="2200" b="1" i="0" dirty="0">
                 <a:solidFill>
                   <a:srgbClr val="5C4826"/>
                 </a:solidFill>
@@ -6449,7 +6449,7 @@
           <a:p>
             <a:pPr algn="ctr"/>
             <a:r>
-              <a:rPr sz="2000" b="1" i="0" dirty="0">
+              <a:rPr sz="2200" b="1" i="0" dirty="0">
                 <a:solidFill>
                   <a:srgbClr val="5C4826"/>
                 </a:solidFill>
@@ -6503,7 +6503,7 @@
           <a:p>
             <a:pPr algn="ctr"/>
             <a:r>
-              <a:rPr sz="2000" b="1" i="0" dirty="0">
+              <a:rPr sz="2200" b="1" i="0" dirty="0">
                 <a:solidFill>
                   <a:srgbClr val="5C4826"/>
                 </a:solidFill>
@@ -6557,7 +6557,7 @@
           <a:p>
             <a:pPr algn="ctr"/>
             <a:r>
-              <a:rPr sz="2000" b="1" i="0" dirty="0">
+              <a:rPr sz="2200" b="1" i="0" dirty="0">
                 <a:solidFill>
                   <a:srgbClr val="5C4826"/>
                 </a:solidFill>
@@ -6611,312 +6611,296 @@
           <a:p>
             <a:pPr algn="ctr"/>
             <a:r>
+              <a:rPr sz="2200" b="1" i="0" dirty="0">
+                <a:solidFill>
+                  <a:srgbClr val="5C4826"/>
+                </a:solidFill>
+              </a:rPr>
+              <a:t>OPERATIONS</a:t>
+            </a:r>
+          </a:p>
+        </p:txBody>
+      </p:sp>
+      <p:sp>
+        <p:nvSpPr>
+          <p:cNvPr id="1015" name="Label"/>
+          <p:cNvSpPr/>
+          <p:nvPr/>
+        </p:nvSpPr>
+        <p:spPr>
+          <a:xfrm>
+            <a:off x="365760" y="4023360"/>
+            <a:ext cx="8412480" cy="1005840"/>
+          </a:xfrm>
+          <a:prstGeom prst="rect">
+            <a:avLst/>
+          </a:prstGeom>
+          <a:noFill/>
+          <a:ln>
+            <a:noFill/>
+          </a:ln>
+          <a:effectLst/>
+        </p:spPr>
+        <p:style>
+          <a:lnRef idx="1">
+            <a:schemeClr val="accent1"/>
+          </a:lnRef>
+          <a:fillRef idx="3">
+            <a:schemeClr val="accent1"/>
+          </a:fillRef>
+          <a:effectRef idx="2">
+            <a:schemeClr val="accent1"/>
+          </a:effectRef>
+          <a:fontRef idx="minor">
+            <a:schemeClr val="lt1"/>
+          </a:fontRef>
+        </p:style>
+        <p:txBody>
+          <a:bodyPr wrap="square" lIns="27432" tIns="22860" rIns="27432" bIns="22860" rtlCol="0" anchor="ctr"/>
+          <a:lstStyle/>
+          <a:p>
+            <a:pPr algn="l"/>
+            <a:r>
+              <a:rPr sz="2200" b="0" i="1" dirty="0">
+                <a:solidFill>
+                  <a:srgbClr val="555960"/>
+                </a:solidFill>
+              </a:rPr>
+              <a:t>Teaching order, not development order. These concerns interact throughout the system's life.</a:t>
+            </a:r>
+          </a:p>
+        </p:txBody>
+      </p:sp>
+      <p:sp>
+        <p:nvSpPr>
+          <p:cNvPr id="1101" name="NumberBadge"/>
+          <p:cNvSpPr/>
+          <p:nvPr/>
+        </p:nvSpPr>
+        <p:spPr>
+          <a:xfrm>
+            <a:off x="173736" y="950976"/>
+            <a:ext cx="384048" cy="384048"/>
+          </a:xfrm>
+          <a:prstGeom prst="ellipse">
+            <a:avLst/>
+          </a:prstGeom>
+          <a:solidFill>
+            <a:srgbClr val="F5F1E8"/>
+          </a:solidFill>
+          <a:ln w="12700">
+            <a:solidFill>
+              <a:srgbClr val="C9B991"/>
+            </a:solidFill>
+          </a:ln>
+        </p:spPr>
+        <p:txBody>
+          <a:bodyPr wrap="square" lIns="0" tIns="0" rIns="0" bIns="0" rtlCol="0" anchor="ctr"/>
+          <a:lstStyle/>
+          <a:p>
+            <a:pPr algn="ctr"/>
+            <a:r>
               <a:rPr sz="2000" b="1" i="0" dirty="0">
                 <a:solidFill>
                   <a:srgbClr val="5C4826"/>
                 </a:solidFill>
               </a:rPr>
-              <a:t>OPERATIONS</a:t>
-            </a:r>
-          </a:p>
-        </p:txBody>
-      </p:sp>
-      <p:cxnSp>
-        <p:nvCxnSpPr>
-          <p:cNvPr id="1008" name="Connector"/>
-          <p:cNvCxnSpPr/>
+              <a:t>1</a:t>
+            </a:r>
+          </a:p>
+        </p:txBody>
+      </p:sp>
+      <p:sp>
+        <p:nvSpPr>
+          <p:cNvPr id="1102" name="NumberBadge"/>
+          <p:cNvSpPr/>
           <p:nvPr/>
-        </p:nvCxnSpPr>
-        <p:spPr>
-          <a:xfrm>
-            <a:off x="2944368" y="1577340"/>
-            <a:ext cx="329184" cy="0"/>
-          </a:xfrm>
-          <a:prstGeom prst="line">
-            <a:avLst/>
-          </a:prstGeom>
-          <a:ln w="19050">
+        </p:nvSpPr>
+        <p:spPr>
+          <a:xfrm>
+            <a:off x="3099816" y="950976"/>
+            <a:ext cx="384048" cy="384048"/>
+          </a:xfrm>
+          <a:prstGeom prst="ellipse">
+            <a:avLst/>
+          </a:prstGeom>
+          <a:solidFill>
+            <a:srgbClr val="F5F1E8"/>
+          </a:solidFill>
+          <a:ln w="12700">
             <a:solidFill>
-              <a:srgbClr val="8E6F3E"/>
-            </a:solidFill>
-            <a:tailEnd type="triangle"/>
-          </a:ln>
-        </p:spPr>
-        <p:style>
-          <a:lnRef idx="2">
-            <a:schemeClr val="accent1"/>
-          </a:lnRef>
-          <a:fillRef idx="0">
-            <a:schemeClr val="accent1"/>
-          </a:fillRef>
-          <a:effectRef idx="1">
-            <a:schemeClr val="accent1"/>
-          </a:effectRef>
-          <a:fontRef idx="minor">
-            <a:schemeClr val="tx1"/>
-          </a:fontRef>
-        </p:style>
-      </p:cxnSp>
-      <p:cxnSp>
-        <p:nvCxnSpPr>
-          <p:cNvPr id="1009" name="Connector"/>
-          <p:cNvCxnSpPr/>
-          <p:nvPr/>
-        </p:nvCxnSpPr>
-        <p:spPr>
-          <a:xfrm>
-            <a:off x="2944368" y="3177540"/>
-            <a:ext cx="329184" cy="0"/>
-          </a:xfrm>
-          <a:prstGeom prst="line">
-            <a:avLst/>
-          </a:prstGeom>
-          <a:ln w="19050">
-            <a:solidFill>
-              <a:srgbClr val="8E6F3E"/>
-            </a:solidFill>
-            <a:tailEnd type="triangle"/>
-          </a:ln>
-        </p:spPr>
-        <p:style>
-          <a:lnRef idx="2">
-            <a:schemeClr val="accent1"/>
-          </a:lnRef>
-          <a:fillRef idx="0">
-            <a:schemeClr val="accent1"/>
-          </a:fillRef>
-          <a:effectRef idx="1">
-            <a:schemeClr val="accent1"/>
-          </a:effectRef>
-          <a:fontRef idx="minor">
-            <a:schemeClr val="tx1"/>
-          </a:fontRef>
-        </p:style>
-      </p:cxnSp>
-      <p:cxnSp>
-        <p:nvCxnSpPr>
-          <p:cNvPr id="1010" name="Connector"/>
-          <p:cNvCxnSpPr/>
-          <p:nvPr/>
-        </p:nvCxnSpPr>
-        <p:spPr>
-          <a:xfrm>
-            <a:off x="5870448" y="1577340"/>
-            <a:ext cx="329184" cy="0"/>
-          </a:xfrm>
-          <a:prstGeom prst="line">
-            <a:avLst/>
-          </a:prstGeom>
-          <a:ln w="19050">
-            <a:solidFill>
-              <a:srgbClr val="8E6F3E"/>
-            </a:solidFill>
-            <a:tailEnd type="triangle"/>
-          </a:ln>
-        </p:spPr>
-        <p:style>
-          <a:lnRef idx="2">
-            <a:schemeClr val="accent1"/>
-          </a:lnRef>
-          <a:fillRef idx="0">
-            <a:schemeClr val="accent1"/>
-          </a:fillRef>
-          <a:effectRef idx="1">
-            <a:schemeClr val="accent1"/>
-          </a:effectRef>
-          <a:fontRef idx="minor">
-            <a:schemeClr val="tx1"/>
-          </a:fontRef>
-        </p:style>
-      </p:cxnSp>
-      <p:cxnSp>
-        <p:nvCxnSpPr>
-          <p:cNvPr id="1011" name="Connector"/>
-          <p:cNvCxnSpPr/>
-          <p:nvPr/>
-        </p:nvCxnSpPr>
-        <p:spPr>
-          <a:xfrm>
-            <a:off x="5870448" y="3177540"/>
-            <a:ext cx="329184" cy="0"/>
-          </a:xfrm>
-          <a:prstGeom prst="line">
-            <a:avLst/>
-          </a:prstGeom>
-          <a:ln w="19050">
-            <a:solidFill>
-              <a:srgbClr val="8E6F3E"/>
-            </a:solidFill>
-            <a:tailEnd type="triangle"/>
-          </a:ln>
-        </p:spPr>
-        <p:style>
-          <a:lnRef idx="2">
-            <a:schemeClr val="accent1"/>
-          </a:lnRef>
-          <a:fillRef idx="0">
-            <a:schemeClr val="accent1"/>
-          </a:fillRef>
-          <a:effectRef idx="1">
-            <a:schemeClr val="accent1"/>
-          </a:effectRef>
-          <a:fontRef idx="minor">
-            <a:schemeClr val="tx1"/>
-          </a:fontRef>
-        </p:style>
-      </p:cxnSp>
-      <p:cxnSp>
-        <p:nvCxnSpPr>
-          <p:cNvPr id="1012" name="Rowwrap down"/>
-          <p:cNvCxnSpPr/>
-          <p:nvPr/>
-        </p:nvCxnSpPr>
-        <p:spPr>
-          <a:xfrm>
-            <a:off x="7498080" y="2020824"/>
-            <a:ext cx="0" cy="374904"/>
-          </a:xfrm>
-          <a:prstGeom prst="line">
-            <a:avLst/>
-          </a:prstGeom>
-          <a:ln w="19050">
-            <a:solidFill>
-              <a:srgbClr val="8E6F3E"/>
+              <a:srgbClr val="C9B991"/>
             </a:solidFill>
           </a:ln>
         </p:spPr>
-        <p:style>
-          <a:lnRef idx="2">
-            <a:schemeClr val="accent1"/>
-          </a:lnRef>
-          <a:fillRef idx="0">
-            <a:schemeClr val="accent1"/>
-          </a:fillRef>
-          <a:effectRef idx="1">
-            <a:schemeClr val="accent1"/>
-          </a:effectRef>
-          <a:fontRef idx="minor">
-            <a:schemeClr val="tx1"/>
-          </a:fontRef>
-        </p:style>
-      </p:cxnSp>
-      <p:cxnSp>
-        <p:nvCxnSpPr>
-          <p:cNvPr id="1013" name="Rowwrap across"/>
-          <p:cNvCxnSpPr/>
+        <p:txBody>
+          <a:bodyPr wrap="square" lIns="0" tIns="0" rIns="0" bIns="0" rtlCol="0" anchor="ctr"/>
+          <a:lstStyle/>
+          <a:p>
+            <a:pPr algn="ctr"/>
+            <a:r>
+              <a:rPr sz="2000" b="1" i="0" dirty="0">
+                <a:solidFill>
+                  <a:srgbClr val="5C4826"/>
+                </a:solidFill>
+              </a:rPr>
+              <a:t>2</a:t>
+            </a:r>
+          </a:p>
+        </p:txBody>
+      </p:sp>
+      <p:sp>
+        <p:nvSpPr>
+          <p:cNvPr id="1103" name="NumberBadge"/>
+          <p:cNvSpPr/>
           <p:nvPr/>
-        </p:nvCxnSpPr>
-        <p:spPr>
-          <a:xfrm>
-            <a:off x="1645920" y="2395728"/>
-            <a:ext cx="5852160" cy="0"/>
-          </a:xfrm>
-          <a:prstGeom prst="line">
-            <a:avLst/>
-          </a:prstGeom>
-          <a:ln w="19050">
+        </p:nvSpPr>
+        <p:spPr>
+          <a:xfrm>
+            <a:off x="6025896" y="950976"/>
+            <a:ext cx="384048" cy="384048"/>
+          </a:xfrm>
+          <a:prstGeom prst="ellipse">
+            <a:avLst/>
+          </a:prstGeom>
+          <a:solidFill>
+            <a:srgbClr val="F5F1E8"/>
+          </a:solidFill>
+          <a:ln w="12700">
             <a:solidFill>
-              <a:srgbClr val="8E6F3E"/>
+              <a:srgbClr val="C9B991"/>
             </a:solidFill>
           </a:ln>
         </p:spPr>
-        <p:style>
-          <a:lnRef idx="2">
-            <a:schemeClr val="accent1"/>
-          </a:lnRef>
-          <a:fillRef idx="0">
-            <a:schemeClr val="accent1"/>
-          </a:fillRef>
-          <a:effectRef idx="1">
-            <a:schemeClr val="accent1"/>
-          </a:effectRef>
-          <a:fontRef idx="minor">
-            <a:schemeClr val="tx1"/>
-          </a:fontRef>
-        </p:style>
-      </p:cxnSp>
-      <p:cxnSp>
-        <p:nvCxnSpPr>
-          <p:cNvPr id="1014" name="Rowwrap into"/>
-          <p:cNvCxnSpPr/>
-          <p:nvPr/>
-        </p:nvCxnSpPr>
-        <p:spPr>
-          <a:xfrm>
-            <a:off x="1645920" y="2395728"/>
-            <a:ext cx="0" cy="338328"/>
-          </a:xfrm>
-          <a:prstGeom prst="line">
-            <a:avLst/>
-          </a:prstGeom>
-          <a:ln w="19050">
-            <a:solidFill>
-              <a:srgbClr val="8E6F3E"/>
-            </a:solidFill>
-            <a:tailEnd type="triangle"/>
-          </a:ln>
-        </p:spPr>
-        <p:style>
-          <a:lnRef idx="2">
-            <a:schemeClr val="accent1"/>
-          </a:lnRef>
-          <a:fillRef idx="0">
-            <a:schemeClr val="accent1"/>
-          </a:fillRef>
-          <a:effectRef idx="1">
-            <a:schemeClr val="accent1"/>
-          </a:effectRef>
-          <a:fontRef idx="minor">
-            <a:schemeClr val="tx1"/>
-          </a:fontRef>
-        </p:style>
-      </p:cxnSp>
-      <p:sp>
-        <p:nvSpPr>
-          <p:cNvPr id="1015" name="Label"/>
+        <p:txBody>
+          <a:bodyPr wrap="square" lIns="0" tIns="0" rIns="0" bIns="0" rtlCol="0" anchor="ctr"/>
+          <a:lstStyle/>
+          <a:p>
+            <a:pPr algn="ctr"/>
+            <a:r>
+              <a:rPr sz="2000" b="1" i="0" dirty="0">
+                <a:solidFill>
+                  <a:srgbClr val="5C4826"/>
+                </a:solidFill>
+              </a:rPr>
+              <a:t>3</a:t>
+            </a:r>
+          </a:p>
+        </p:txBody>
+      </p:sp>
+      <p:sp>
+        <p:nvSpPr>
+          <p:cNvPr id="1104" name="NumberBadge"/>
           <p:cNvSpPr/>
           <p:nvPr/>
         </p:nvSpPr>
         <p:spPr>
           <a:xfrm>
-            <a:off x="365760" y="4023360"/>
-            <a:ext cx="8412480" cy="1005840"/>
-          </a:xfrm>
-          <a:prstGeom prst="rect">
-            <a:avLst/>
-          </a:prstGeom>
-          <a:noFill/>
-          <a:ln>
-            <a:noFill/>
+            <a:off x="173736" y="2551176"/>
+            <a:ext cx="384048" cy="384048"/>
+          </a:xfrm>
+          <a:prstGeom prst="ellipse">
+            <a:avLst/>
+          </a:prstGeom>
+          <a:solidFill>
+            <a:srgbClr val="F5F1E8"/>
+          </a:solidFill>
+          <a:ln w="12700">
+            <a:solidFill>
+              <a:srgbClr val="C9B991"/>
+            </a:solidFill>
           </a:ln>
-          <a:effectLst/>
-        </p:spPr>
-        <p:style>
-          <a:lnRef idx="1">
-            <a:schemeClr val="accent1"/>
-          </a:lnRef>
-          <a:fillRef idx="3">
-            <a:schemeClr val="accent1"/>
-          </a:fillRef>
-          <a:effectRef idx="2">
-            <a:schemeClr val="accent1"/>
-          </a:effectRef>
-          <a:fontRef idx="minor">
-            <a:schemeClr val="lt1"/>
-          </a:fontRef>
-        </p:style>
-        <p:txBody>
-          <a:bodyPr wrap="square" lIns="27432" tIns="22860" rIns="27432" bIns="22860" rtlCol="0" anchor="ctr"/>
-          <a:lstStyle/>
-          <a:p>
-            <a:pPr algn="l"/>
-            <a:r>
-              <a:rPr sz="2000" b="0" i="1" dirty="0">
+        </p:spPr>
+        <p:txBody>
+          <a:bodyPr wrap="square" lIns="0" tIns="0" rIns="0" bIns="0" rtlCol="0" anchor="ctr"/>
+          <a:lstStyle/>
+          <a:p>
+            <a:pPr algn="ctr"/>
+            <a:r>
+              <a:rPr sz="2000" b="1" i="0" dirty="0">
                 <a:solidFill>
-                  <a:srgbClr val="555960"/>
+                  <a:srgbClr val="5C4826"/>
                 </a:solidFill>
               </a:rPr>
-              <a:t>This is the teaching order, not the order the concerns arrive. Security shapes architecture from the start; operations shape deployment.</a:t>
+              <a:t>4</a:t>
+            </a:r>
+          </a:p>
+        </p:txBody>
+      </p:sp>
+      <p:sp>
+        <p:nvSpPr>
+          <p:cNvPr id="1105" name="NumberBadge"/>
+          <p:cNvSpPr/>
+          <p:nvPr/>
+        </p:nvSpPr>
+        <p:spPr>
+          <a:xfrm>
+            <a:off x="3099816" y="2551176"/>
+            <a:ext cx="384048" cy="384048"/>
+          </a:xfrm>
+          <a:prstGeom prst="ellipse">
+            <a:avLst/>
+          </a:prstGeom>
+          <a:solidFill>
+            <a:srgbClr val="F5F1E8"/>
+          </a:solidFill>
+          <a:ln w="12700">
+            <a:solidFill>
+              <a:srgbClr val="C9B991"/>
+            </a:solidFill>
+          </a:ln>
+        </p:spPr>
+        <p:txBody>
+          <a:bodyPr wrap="square" lIns="0" tIns="0" rIns="0" bIns="0" rtlCol="0" anchor="ctr"/>
+          <a:lstStyle/>
+          <a:p>
+            <a:pPr algn="ctr"/>
+            <a:r>
+              <a:rPr sz="2000" b="1" i="0" dirty="0">
+                <a:solidFill>
+                  <a:srgbClr val="5C4826"/>
+                </a:solidFill>
+              </a:rPr>
+              <a:t>5</a:t>
+            </a:r>
+          </a:p>
+        </p:txBody>
+      </p:sp>
+      <p:sp>
+        <p:nvSpPr>
+          <p:cNvPr id="1106" name="NumberBadge"/>
+          <p:cNvSpPr/>
+          <p:nvPr/>
+        </p:nvSpPr>
+        <p:spPr>
+          <a:xfrm>
+            <a:off x="6025896" y="2551176"/>
+            <a:ext cx="384048" cy="384048"/>
+          </a:xfrm>
+          <a:prstGeom prst="ellipse">
+            <a:avLst/>
+          </a:prstGeom>
+          <a:solidFill>
+            <a:srgbClr val="F5F1E8"/>
+          </a:solidFill>
+          <a:ln w="12700">
+            <a:solidFill>
+              <a:srgbClr val="C9B991"/>
+            </a:solidFill>
+          </a:ln>
+        </p:spPr>
+        <p:txBody>
+          <a:bodyPr wrap="square" lIns="0" tIns="0" rIns="0" bIns="0" rtlCol="0" anchor="ctr"/>
+          <a:lstStyle/>
+          <a:p>
+            <a:pPr algn="ctr"/>
+            <a:r>
+              <a:rPr sz="2000" b="1" i="0" dirty="0">
+                <a:solidFill>
+                  <a:srgbClr val="5C4826"/>
+                </a:solidFill>
+              </a:rPr>
+              <a:t>6</a:t>
             </a:r>
           </a:p>
         </p:txBody>
@@ -7681,7 +7665,7 @@
             <a:p>
               <a:pPr algn="r"/>
               <a:r>
-                <a:rPr sz="2000" b="0" i="0" dirty="0">
+                <a:rPr sz="2200" b="0" i="0" dirty="0">
                   <a:solidFill>
                     <a:srgbClr val="555960"/>
                   </a:solidFill>
@@ -7699,8 +7683,8 @@
           </p:nvSpPr>
           <p:spPr>
             <a:xfrm>
-              <a:off x="4663440" y="4553712"/>
-              <a:ext cx="4114800" cy="685800"/>
+              <a:off x="4526280" y="4553712"/>
+              <a:ext cx="4343400" cy="685800"/>
             </a:xfrm>
             <a:prstGeom prst="rect">
               <a:avLst/>
@@ -7731,7 +7715,7 @@
             <a:p>
               <a:pPr algn="l"/>
               <a:r>
-                <a:rPr sz="2000" b="0" i="0" dirty="0">
+                <a:rPr sz="2200" b="0" i="0" dirty="0">
                   <a:solidFill>
                     <a:srgbClr val="555960"/>
                   </a:solidFill>
@@ -9322,7 +9306,7 @@
           <a:p>
             <a:pPr algn="l"/>
             <a:r>
-              <a:rPr sz="2000" b="1" i="0" dirty="0">
+              <a:rPr sz="2200" b="1" i="0" dirty="0">
                 <a:solidFill>
                   <a:srgbClr val="5C4826"/>
                 </a:solidFill>
@@ -9374,7 +9358,7 @@
           <a:p>
             <a:pPr algn="ctr"/>
             <a:r>
-              <a:rPr sz="2000" b="1" i="0" dirty="0">
+              <a:rPr sz="2200" b="1" i="0" dirty="0">
                 <a:solidFill>
                   <a:srgbClr val="FFFFFF"/>
                 </a:solidFill>
@@ -9426,7 +9410,7 @@
           <a:p>
             <a:pPr algn="ctr"/>
             <a:r>
-              <a:rPr sz="2000" b="1" i="0" dirty="0">
+              <a:rPr sz="2200" b="1" i="0" dirty="0">
                 <a:solidFill>
                   <a:srgbClr val="FFFFFF"/>
                 </a:solidFill>
@@ -9514,7 +9498,7 @@
           <a:p>
             <a:pPr algn="ctr"/>
             <a:r>
-              <a:rPr sz="2000" b="1" i="0" dirty="0">
+              <a:rPr sz="2200" b="1" i="0" dirty="0">
                 <a:solidFill>
                   <a:srgbClr val="FFFFFF"/>
                 </a:solidFill>
@@ -9569,7 +9553,7 @@
         <p:spPr>
           <a:xfrm>
             <a:off x="731520" y="4407408"/>
-            <a:ext cx="2468880" cy="658368"/>
+            <a:ext cx="2468880" cy="777240"/>
           </a:xfrm>
           <a:prstGeom prst="rect">
             <a:avLst/>
@@ -9602,7 +9586,7 @@
           <a:p>
             <a:pPr algn="ctr"/>
             <a:r>
-              <a:rPr sz="2000" b="1" i="0" dirty="0">
+              <a:rPr sz="2200" b="1" i="0" dirty="0">
                 <a:solidFill>
                   <a:srgbClr val="FFFFFF"/>
                 </a:solidFill>
@@ -9688,7 +9672,7 @@
           <a:p>
             <a:pPr algn="ctr"/>
             <a:r>
-              <a:rPr sz="2000" b="0" i="1" dirty="0">
+              <a:rPr sz="2200" b="0" i="1" dirty="0">
                 <a:solidFill>
                   <a:srgbClr val="555960"/>
                 </a:solidFill>
@@ -10008,7 +9992,7 @@
           <a:p>
             <a:pPr algn="ctr"/>
             <a:r>
-              <a:rPr sz="2000" b="0" i="1" dirty="0">
+              <a:rPr sz="2200" b="0" i="1" dirty="0">
                 <a:solidFill>
                   <a:srgbClr val="555960"/>
                 </a:solidFill>
@@ -10515,7 +10499,7 @@
           <a:p>
             <a:pPr algn="ctr"/>
             <a:r>
-              <a:rPr sz="2000" b="1" i="0" dirty="0">
+              <a:rPr sz="2200" b="1" i="0" dirty="0">
                 <a:solidFill>
                   <a:srgbClr val="FFFFFF"/>
                 </a:solidFill>

</xml_diff>

<commit_message>
3-0 kickoff slide 4: convert method flowchart to the two-row serpentine
Align the Act III engineering-method motif with 3-1 s25 / 3-2 s28: top row
PROBLEM -> MODEL -> JUDGMENT, right-side drop, lower row REALIZE -> EVIDENCE ->
ACCEPT / REJECT with left-pointing arrowheads (verified in render). Feedback
paths rebuilt for the new geometry: grey LOCAL REVISION as a short custGeom U
hop Evidence -> Realize; gold ENGINEERING REVISION as a vertical return
Evidence -> Model across the row boundary. ALIGNMENT stays alongside, its two
up-arrows re-anchored to the new Realize/Evidence bottoms.

Co-Authored-By: Claude Opus 5 <noreply@anthropic.com>
</commit_message>
<xml_diff>
--- a/course/lectures/act-3-software-in-the-world/3-0-Act-III-Kickoff.pptx
+++ b/course/lectures/act-3-software-in-the-world/3-0-Act-III-Kickoff.pptx
@@ -6973,774 +6973,23 @@
           </a:p>
         </p:txBody>
       </p:sp>
-      <p:grpSp>
-        <p:nvGrpSpPr>
-          <p:cNvPr id="1002" name="MethodFlow"/>
-          <p:cNvGrpSpPr/>
-          <p:nvPr/>
-        </p:nvGrpSpPr>
-        <p:grpSpPr>
-          <a:xfrm>
-            <a:off x="274320" y="1097280"/>
-            <a:ext cx="8613648" cy="4160520"/>
-            <a:chOff x="274320" y="1097280"/>
-            <a:chExt cx="8613648" cy="4160520"/>
-          </a:xfrm>
-        </p:grpSpPr>
-        <p:sp>
-          <p:nvSpPr>
-            <p:cNvPr id="1003" name="Method Problem"/>
-            <p:cNvSpPr/>
-            <p:nvPr/>
-          </p:nvSpPr>
-          <p:spPr>
-            <a:xfrm>
-              <a:off x="292608" y="2148840"/>
-              <a:ext cx="1298448" cy="868680"/>
-            </a:xfrm>
-            <a:prstGeom prst="rect">
-              <a:avLst/>
-            </a:prstGeom>
-            <a:solidFill>
-              <a:srgbClr val="8E6F3E"/>
-            </a:solidFill>
-            <a:ln>
-              <a:noFill/>
-            </a:ln>
-            <a:effectLst/>
-          </p:spPr>
-          <p:style>
-            <a:lnRef idx="1">
-              <a:schemeClr val="accent1"/>
-            </a:lnRef>
-            <a:fillRef idx="3">
-              <a:schemeClr val="accent1"/>
-            </a:fillRef>
-            <a:effectRef idx="2">
-              <a:schemeClr val="accent1"/>
-            </a:effectRef>
-            <a:fontRef idx="minor">
-              <a:schemeClr val="lt1"/>
-            </a:fontRef>
-          </p:style>
-          <p:txBody>
-            <a:bodyPr wrap="square" lIns="27432" tIns="22860" rIns="27432" bIns="22860" rtlCol="0" anchor="ctr"/>
-            <a:lstStyle/>
-            <a:p>
-              <a:pPr algn="ctr"/>
-              <a:r>
-                <a:rPr sz="2200" b="1" i="0" dirty="0">
-                  <a:solidFill>
-                    <a:srgbClr val="FFFFFF"/>
-                  </a:solidFill>
-                </a:rPr>
-                <a:t>Problem</a:t>
-              </a:r>
-            </a:p>
-          </p:txBody>
-        </p:sp>
-        <p:sp>
-          <p:nvSpPr>
-            <p:cNvPr id="1004" name="Method Model"/>
-            <p:cNvSpPr/>
-            <p:nvPr/>
-          </p:nvSpPr>
-          <p:spPr>
-            <a:xfrm>
-              <a:off x="1746504" y="2148840"/>
-              <a:ext cx="1298448" cy="868680"/>
-            </a:xfrm>
-            <a:prstGeom prst="rect">
-              <a:avLst/>
-            </a:prstGeom>
-            <a:solidFill>
-              <a:srgbClr val="8E6F3E"/>
-            </a:solidFill>
-            <a:ln>
-              <a:noFill/>
-            </a:ln>
-            <a:effectLst/>
-          </p:spPr>
-          <p:style>
-            <a:lnRef idx="1">
-              <a:schemeClr val="accent1"/>
-            </a:lnRef>
-            <a:fillRef idx="3">
-              <a:schemeClr val="accent1"/>
-            </a:fillRef>
-            <a:effectRef idx="2">
-              <a:schemeClr val="accent1"/>
-            </a:effectRef>
-            <a:fontRef idx="minor">
-              <a:schemeClr val="lt1"/>
-            </a:fontRef>
-          </p:style>
-          <p:txBody>
-            <a:bodyPr wrap="square" lIns="27432" tIns="22860" rIns="27432" bIns="22860" rtlCol="0" anchor="ctr"/>
-            <a:lstStyle/>
-            <a:p>
-              <a:pPr algn="ctr"/>
-              <a:r>
-                <a:rPr sz="2200" b="1" i="0" dirty="0">
-                  <a:solidFill>
-                    <a:srgbClr val="FFFFFF"/>
-                  </a:solidFill>
-                </a:rPr>
-                <a:t>Model</a:t>
-              </a:r>
-            </a:p>
-          </p:txBody>
-        </p:sp>
-        <p:sp>
-          <p:nvSpPr>
-            <p:cNvPr id="1005" name="Method Judgment"/>
-            <p:cNvSpPr/>
-            <p:nvPr/>
-          </p:nvSpPr>
-          <p:spPr>
-            <a:xfrm>
-              <a:off x="3200400" y="2148840"/>
-              <a:ext cx="1298448" cy="868680"/>
-            </a:xfrm>
-            <a:prstGeom prst="rect">
-              <a:avLst/>
-            </a:prstGeom>
-            <a:solidFill>
-              <a:srgbClr val="8E6F3E"/>
-            </a:solidFill>
-            <a:ln>
-              <a:noFill/>
-            </a:ln>
-            <a:effectLst/>
-          </p:spPr>
-          <p:style>
-            <a:lnRef idx="1">
-              <a:schemeClr val="accent1"/>
-            </a:lnRef>
-            <a:fillRef idx="3">
-              <a:schemeClr val="accent1"/>
-            </a:fillRef>
-            <a:effectRef idx="2">
-              <a:schemeClr val="accent1"/>
-            </a:effectRef>
-            <a:fontRef idx="minor">
-              <a:schemeClr val="lt1"/>
-            </a:fontRef>
-          </p:style>
-          <p:txBody>
-            <a:bodyPr wrap="square" lIns="27432" tIns="22860" rIns="27432" bIns="22860" rtlCol="0" anchor="ctr"/>
-            <a:lstStyle/>
-            <a:p>
-              <a:pPr algn="ctr"/>
-              <a:r>
-                <a:rPr sz="2200" b="1" i="0" dirty="0">
-                  <a:solidFill>
-                    <a:srgbClr val="FFFFFF"/>
-                  </a:solidFill>
-                </a:rPr>
-                <a:t>Judgment</a:t>
-              </a:r>
-            </a:p>
-          </p:txBody>
-        </p:sp>
-        <p:sp>
-          <p:nvSpPr>
-            <p:cNvPr id="1006" name="Method Realize"/>
-            <p:cNvSpPr/>
-            <p:nvPr/>
-          </p:nvSpPr>
-          <p:spPr>
-            <a:xfrm>
-              <a:off x="4654296" y="2148840"/>
-              <a:ext cx="1298448" cy="868680"/>
-            </a:xfrm>
-            <a:prstGeom prst="rect">
-              <a:avLst/>
-            </a:prstGeom>
-            <a:solidFill>
-              <a:srgbClr val="8E6F3E"/>
-            </a:solidFill>
-            <a:ln>
-              <a:noFill/>
-            </a:ln>
-            <a:effectLst/>
-          </p:spPr>
-          <p:style>
-            <a:lnRef idx="1">
-              <a:schemeClr val="accent1"/>
-            </a:lnRef>
-            <a:fillRef idx="3">
-              <a:schemeClr val="accent1"/>
-            </a:fillRef>
-            <a:effectRef idx="2">
-              <a:schemeClr val="accent1"/>
-            </a:effectRef>
-            <a:fontRef idx="minor">
-              <a:schemeClr val="lt1"/>
-            </a:fontRef>
-          </p:style>
-          <p:txBody>
-            <a:bodyPr wrap="square" lIns="27432" tIns="22860" rIns="27432" bIns="22860" rtlCol="0" anchor="ctr"/>
-            <a:lstStyle/>
-            <a:p>
-              <a:pPr algn="ctr"/>
-              <a:r>
-                <a:rPr sz="2200" b="1" i="0" dirty="0">
-                  <a:solidFill>
-                    <a:srgbClr val="FFFFFF"/>
-                  </a:solidFill>
-                </a:rPr>
-                <a:t>Realize</a:t>
-              </a:r>
-            </a:p>
-          </p:txBody>
-        </p:sp>
-        <p:sp>
-          <p:nvSpPr>
-            <p:cNvPr id="1007" name="Method Evidence"/>
-            <p:cNvSpPr/>
-            <p:nvPr/>
-          </p:nvSpPr>
-          <p:spPr>
-            <a:xfrm>
-              <a:off x="6108192" y="2148840"/>
-              <a:ext cx="1298448" cy="868680"/>
-            </a:xfrm>
-            <a:prstGeom prst="rect">
-              <a:avLst/>
-            </a:prstGeom>
-            <a:solidFill>
-              <a:srgbClr val="8E6F3E"/>
-            </a:solidFill>
-            <a:ln>
-              <a:noFill/>
-            </a:ln>
-            <a:effectLst/>
-          </p:spPr>
-          <p:style>
-            <a:lnRef idx="1">
-              <a:schemeClr val="accent1"/>
-            </a:lnRef>
-            <a:fillRef idx="3">
-              <a:schemeClr val="accent1"/>
-            </a:fillRef>
-            <a:effectRef idx="2">
-              <a:schemeClr val="accent1"/>
-            </a:effectRef>
-            <a:fontRef idx="minor">
-              <a:schemeClr val="lt1"/>
-            </a:fontRef>
-          </p:style>
-          <p:txBody>
-            <a:bodyPr wrap="square" lIns="27432" tIns="22860" rIns="27432" bIns="22860" rtlCol="0" anchor="ctr"/>
-            <a:lstStyle/>
-            <a:p>
-              <a:pPr algn="ctr"/>
-              <a:r>
-                <a:rPr sz="2200" b="1" i="0" dirty="0">
-                  <a:solidFill>
-                    <a:srgbClr val="FFFFFF"/>
-                  </a:solidFill>
-                </a:rPr>
-                <a:t>Evidence</a:t>
-              </a:r>
-            </a:p>
-          </p:txBody>
-        </p:sp>
-        <p:sp>
-          <p:nvSpPr>
-            <p:cNvPr id="1008" name="Method Accept / reject"/>
-            <p:cNvSpPr/>
-            <p:nvPr/>
-          </p:nvSpPr>
-          <p:spPr>
-            <a:xfrm>
-              <a:off x="7562088" y="2148840"/>
-              <a:ext cx="1298448" cy="868680"/>
-            </a:xfrm>
-            <a:prstGeom prst="rect">
-              <a:avLst/>
-            </a:prstGeom>
-            <a:solidFill>
-              <a:srgbClr val="8E6F3E"/>
-            </a:solidFill>
-            <a:ln>
-              <a:noFill/>
-            </a:ln>
-            <a:effectLst/>
-          </p:spPr>
-          <p:style>
-            <a:lnRef idx="1">
-              <a:schemeClr val="accent1"/>
-            </a:lnRef>
-            <a:fillRef idx="3">
-              <a:schemeClr val="accent1"/>
-            </a:fillRef>
-            <a:effectRef idx="2">
-              <a:schemeClr val="accent1"/>
-            </a:effectRef>
-            <a:fontRef idx="minor">
-              <a:schemeClr val="lt1"/>
-            </a:fontRef>
-          </p:style>
-          <p:txBody>
-            <a:bodyPr wrap="square" lIns="27432" tIns="22860" rIns="27432" bIns="22860" rtlCol="0" anchor="ctr"/>
-            <a:lstStyle/>
-            <a:p>
-              <a:pPr algn="ctr"/>
-              <a:r>
-                <a:rPr sz="2200" b="1" i="0" dirty="0">
-                  <a:solidFill>
-                    <a:srgbClr val="FFFFFF"/>
-                  </a:solidFill>
-                </a:rPr>
-                <a:t>Accept/</a:t>
-              </a:r>
-            </a:p>
-            <a:p>
-              <a:pPr algn="ctr"/>
-              <a:r>
-                <a:rPr sz="2200" b="1" i="0" dirty="0">
-                  <a:solidFill>
-                    <a:srgbClr val="FFFFFF"/>
-                  </a:solidFill>
-                </a:rPr>
-                <a:t>reject</a:t>
-              </a:r>
-            </a:p>
-          </p:txBody>
-        </p:sp>
-        <p:cxnSp>
-          <p:nvCxnSpPr>
-            <p:cNvPr id="1009" name="Connector"/>
-            <p:cNvCxnSpPr/>
-            <p:nvPr/>
-          </p:nvCxnSpPr>
-          <p:spPr>
-            <a:xfrm>
-              <a:off x="1600200" y="2583180"/>
-              <a:ext cx="137160" cy="0"/>
-            </a:xfrm>
-            <a:prstGeom prst="line">
-              <a:avLst/>
-            </a:prstGeom>
-            <a:ln w="19050">
-              <a:solidFill>
-                <a:srgbClr val="8E6F3E"/>
-              </a:solidFill>
-              <a:tailEnd type="triangle"/>
-            </a:ln>
-          </p:spPr>
-          <p:style>
-            <a:lnRef idx="2">
-              <a:schemeClr val="accent1"/>
-            </a:lnRef>
-            <a:fillRef idx="0">
-              <a:schemeClr val="accent1"/>
-            </a:fillRef>
-            <a:effectRef idx="1">
-              <a:schemeClr val="accent1"/>
-            </a:effectRef>
-            <a:fontRef idx="minor">
-              <a:schemeClr val="tx1"/>
-            </a:fontRef>
-          </p:style>
-        </p:cxnSp>
-        <p:cxnSp>
-          <p:nvCxnSpPr>
-            <p:cNvPr id="1010" name="Connector"/>
-            <p:cNvCxnSpPr/>
-            <p:nvPr/>
-          </p:nvCxnSpPr>
-          <p:spPr>
-            <a:xfrm>
-              <a:off x="3054096" y="2583180"/>
-              <a:ext cx="137160" cy="0"/>
-            </a:xfrm>
-            <a:prstGeom prst="line">
-              <a:avLst/>
-            </a:prstGeom>
-            <a:ln w="19050">
-              <a:solidFill>
-                <a:srgbClr val="8E6F3E"/>
-              </a:solidFill>
-              <a:tailEnd type="triangle"/>
-            </a:ln>
-          </p:spPr>
-          <p:style>
-            <a:lnRef idx="2">
-              <a:schemeClr val="accent1"/>
-            </a:lnRef>
-            <a:fillRef idx="0">
-              <a:schemeClr val="accent1"/>
-            </a:fillRef>
-            <a:effectRef idx="1">
-              <a:schemeClr val="accent1"/>
-            </a:effectRef>
-            <a:fontRef idx="minor">
-              <a:schemeClr val="tx1"/>
-            </a:fontRef>
-          </p:style>
-        </p:cxnSp>
-        <p:cxnSp>
-          <p:nvCxnSpPr>
-            <p:cNvPr id="1011" name="Connector"/>
-            <p:cNvCxnSpPr/>
-            <p:nvPr/>
-          </p:nvCxnSpPr>
-          <p:spPr>
-            <a:xfrm>
-              <a:off x="4507992" y="2583180"/>
-              <a:ext cx="137160" cy="0"/>
-            </a:xfrm>
-            <a:prstGeom prst="line">
-              <a:avLst/>
-            </a:prstGeom>
-            <a:ln w="19050">
-              <a:solidFill>
-                <a:srgbClr val="8E6F3E"/>
-              </a:solidFill>
-              <a:tailEnd type="triangle"/>
-            </a:ln>
-          </p:spPr>
-          <p:style>
-            <a:lnRef idx="2">
-              <a:schemeClr val="accent1"/>
-            </a:lnRef>
-            <a:fillRef idx="0">
-              <a:schemeClr val="accent1"/>
-            </a:fillRef>
-            <a:effectRef idx="1">
-              <a:schemeClr val="accent1"/>
-            </a:effectRef>
-            <a:fontRef idx="minor">
-              <a:schemeClr val="tx1"/>
-            </a:fontRef>
-          </p:style>
-        </p:cxnSp>
-        <p:cxnSp>
-          <p:nvCxnSpPr>
-            <p:cNvPr id="1012" name="Connector"/>
-            <p:cNvCxnSpPr/>
-            <p:nvPr/>
-          </p:nvCxnSpPr>
-          <p:spPr>
-            <a:xfrm>
-              <a:off x="5961888" y="2583180"/>
-              <a:ext cx="137160" cy="0"/>
-            </a:xfrm>
-            <a:prstGeom prst="line">
-              <a:avLst/>
-            </a:prstGeom>
-            <a:ln w="19050">
-              <a:solidFill>
-                <a:srgbClr val="8E6F3E"/>
-              </a:solidFill>
-              <a:tailEnd type="triangle"/>
-            </a:ln>
-          </p:spPr>
-          <p:style>
-            <a:lnRef idx="2">
-              <a:schemeClr val="accent1"/>
-            </a:lnRef>
-            <a:fillRef idx="0">
-              <a:schemeClr val="accent1"/>
-            </a:fillRef>
-            <a:effectRef idx="1">
-              <a:schemeClr val="accent1"/>
-            </a:effectRef>
-            <a:fontRef idx="minor">
-              <a:schemeClr val="tx1"/>
-            </a:fontRef>
-          </p:style>
-        </p:cxnSp>
-        <p:cxnSp>
-          <p:nvCxnSpPr>
-            <p:cNvPr id="1013" name="Connector"/>
-            <p:cNvCxnSpPr/>
-            <p:nvPr/>
-          </p:nvCxnSpPr>
-          <p:spPr>
-            <a:xfrm>
-              <a:off x="7415784" y="2583180"/>
-              <a:ext cx="137160" cy="0"/>
-            </a:xfrm>
-            <a:prstGeom prst="line">
-              <a:avLst/>
-            </a:prstGeom>
-            <a:ln w="19050">
-              <a:solidFill>
-                <a:srgbClr val="8E6F3E"/>
-              </a:solidFill>
-              <a:tailEnd type="triangle"/>
-            </a:ln>
-          </p:spPr>
-          <p:style>
-            <a:lnRef idx="2">
-              <a:schemeClr val="accent1"/>
-            </a:lnRef>
-            <a:fillRef idx="0">
-              <a:schemeClr val="accent1"/>
-            </a:fillRef>
-            <a:effectRef idx="1">
-              <a:schemeClr val="accent1"/>
-            </a:effectRef>
-            <a:fontRef idx="minor">
-              <a:schemeClr val="tx1"/>
-            </a:fontRef>
-          </p:style>
-        </p:cxnSp>
-        <p:sp>
-          <p:nvSpPr>
-            <p:cNvPr id="1018" name="Method Alignment"/>
-            <p:cNvSpPr/>
-            <p:nvPr/>
-          </p:nvSpPr>
-          <p:spPr>
-            <a:xfrm>
-              <a:off x="4663440" y="3703320"/>
-              <a:ext cx="2834640" cy="731520"/>
-            </a:xfrm>
-            <a:prstGeom prst="rect">
-              <a:avLst/>
-            </a:prstGeom>
-            <a:solidFill>
-              <a:srgbClr val="3E5C6F"/>
-            </a:solidFill>
-            <a:ln>
-              <a:noFill/>
-            </a:ln>
-            <a:effectLst/>
-          </p:spPr>
-          <p:style>
-            <a:lnRef idx="1">
-              <a:schemeClr val="accent1"/>
-            </a:lnRef>
-            <a:fillRef idx="3">
-              <a:schemeClr val="accent1"/>
-            </a:fillRef>
-            <a:effectRef idx="2">
-              <a:schemeClr val="accent1"/>
-            </a:effectRef>
-            <a:fontRef idx="minor">
-              <a:schemeClr val="lt1"/>
-            </a:fontRef>
-          </p:style>
-          <p:txBody>
-            <a:bodyPr wrap="square" lIns="27432" tIns="22860" rIns="27432" bIns="22860" rtlCol="0" anchor="ctr"/>
-            <a:lstStyle/>
-            <a:p>
-              <a:pPr algn="ctr"/>
-              <a:r>
-                <a:rPr sz="2200" b="1" i="0" dirty="0">
-                  <a:solidFill>
-                    <a:srgbClr val="FFFFFF"/>
-                  </a:solidFill>
-                </a:rPr>
-                <a:t>ALIGNMENT</a:t>
-              </a:r>
-            </a:p>
-            <a:p>
-              <a:pPr algn="ctr"/>
-              <a:r>
-                <a:rPr sz="2200" b="0" i="0" dirty="0">
-                  <a:solidFill>
-                    <a:srgbClr val="FFFFFF"/>
-                  </a:solidFill>
-                </a:rPr>
-                <a:t>(from Act II)</a:t>
-              </a:r>
-            </a:p>
-          </p:txBody>
-        </p:sp>
-        <p:cxnSp>
-          <p:nvCxnSpPr>
-            <p:cNvPr id="1019" name="Align to Realize"/>
-            <p:cNvCxnSpPr/>
-            <p:nvPr/>
-          </p:nvCxnSpPr>
-          <p:spPr>
-            <a:xfrm flipV="1">
-              <a:off x="5303520" y="3026664"/>
-              <a:ext cx="0" cy="676656"/>
-            </a:xfrm>
-            <a:prstGeom prst="line">
-              <a:avLst/>
-            </a:prstGeom>
-            <a:ln w="19050">
-              <a:solidFill>
-                <a:srgbClr val="8E6F3E"/>
-              </a:solidFill>
-              <a:tailEnd type="triangle"/>
-            </a:ln>
-          </p:spPr>
-          <p:style>
-            <a:lnRef idx="2">
-              <a:schemeClr val="accent1"/>
-            </a:lnRef>
-            <a:fillRef idx="0">
-              <a:schemeClr val="accent1"/>
-            </a:fillRef>
-            <a:effectRef idx="1">
-              <a:schemeClr val="accent1"/>
-            </a:effectRef>
-            <a:fontRef idx="minor">
-              <a:schemeClr val="tx1"/>
-            </a:fontRef>
-          </p:style>
-        </p:cxnSp>
-        <p:cxnSp>
-          <p:nvCxnSpPr>
-            <p:cNvPr id="1020" name="Align to Evidence"/>
-            <p:cNvCxnSpPr/>
-            <p:nvPr/>
-          </p:nvCxnSpPr>
-          <p:spPr>
-            <a:xfrm flipV="1">
-              <a:off x="6757416" y="3026664"/>
-              <a:ext cx="0" cy="676656"/>
-            </a:xfrm>
-            <a:prstGeom prst="line">
-              <a:avLst/>
-            </a:prstGeom>
-            <a:ln w="19050">
-              <a:solidFill>
-                <a:srgbClr val="8E6F3E"/>
-              </a:solidFill>
-              <a:tailEnd type="triangle"/>
-            </a:ln>
-          </p:spPr>
-          <p:style>
-            <a:lnRef idx="2">
-              <a:schemeClr val="accent1"/>
-            </a:lnRef>
-            <a:fillRef idx="0">
-              <a:schemeClr val="accent1"/>
-            </a:fillRef>
-            <a:effectRef idx="1">
-              <a:schemeClr val="accent1"/>
-            </a:effectRef>
-            <a:fontRef idx="minor">
-              <a:schemeClr val="tx1"/>
-            </a:fontRef>
-          </p:style>
-        </p:cxnSp>
-        <p:sp>
-          <p:nvSpPr>
-            <p:cNvPr id="1021" name="Align caption L"/>
-            <p:cNvSpPr/>
-            <p:nvPr/>
-          </p:nvSpPr>
-          <p:spPr>
-            <a:xfrm>
-              <a:off x="777240" y="3255264"/>
-              <a:ext cx="4407408" cy="384048"/>
-            </a:xfrm>
-            <a:prstGeom prst="rect">
-              <a:avLst/>
-            </a:prstGeom>
-            <a:noFill/>
-            <a:ln>
-              <a:noFill/>
-            </a:ln>
-            <a:effectLst/>
-          </p:spPr>
-          <p:style>
-            <a:lnRef idx="1">
-              <a:schemeClr val="accent1"/>
-            </a:lnRef>
-            <a:fillRef idx="3">
-              <a:schemeClr val="accent1"/>
-            </a:fillRef>
-            <a:effectRef idx="2">
-              <a:schemeClr val="accent1"/>
-            </a:effectRef>
-            <a:fontRef idx="minor">
-              <a:schemeClr val="lt1"/>
-            </a:fontRef>
-          </p:style>
-          <p:txBody>
-            <a:bodyPr wrap="square" lIns="27432" tIns="22860" rIns="27432" bIns="22860" rtlCol="0" anchor="ctr"/>
-            <a:lstStyle/>
-            <a:p>
-              <a:pPr algn="r"/>
-              <a:r>
-                <a:rPr sz="2200" b="0" i="0" dirty="0">
-                  <a:solidFill>
-                    <a:srgbClr val="555960"/>
-                  </a:solidFill>
-                </a:rPr>
-                <a:t>constraints govern realization</a:t>
-              </a:r>
-            </a:p>
-          </p:txBody>
-        </p:sp>
-        <p:sp>
-          <p:nvSpPr>
-            <p:cNvPr id="1022" name="Align caption R"/>
-            <p:cNvSpPr/>
-            <p:nvPr/>
-          </p:nvSpPr>
-          <p:spPr>
-            <a:xfrm>
-              <a:off x="4526280" y="4553712"/>
-              <a:ext cx="4343400" cy="685800"/>
-            </a:xfrm>
-            <a:prstGeom prst="rect">
-              <a:avLst/>
-            </a:prstGeom>
-            <a:noFill/>
-            <a:ln>
-              <a:noFill/>
-            </a:ln>
-            <a:effectLst/>
-          </p:spPr>
-          <p:style>
-            <a:lnRef idx="1">
-              <a:schemeClr val="accent1"/>
-            </a:lnRef>
-            <a:fillRef idx="3">
-              <a:schemeClr val="accent1"/>
-            </a:fillRef>
-            <a:effectRef idx="2">
-              <a:schemeClr val="accent1"/>
-            </a:effectRef>
-            <a:fontRef idx="minor">
-              <a:schemeClr val="lt1"/>
-            </a:fontRef>
-          </p:style>
-          <p:txBody>
-            <a:bodyPr wrap="square" lIns="27432" tIns="22860" rIns="27432" bIns="22860" rtlCol="0" anchor="ctr"/>
-            <a:lstStyle/>
-            <a:p>
-              <a:pPr algn="l"/>
-              <a:r>
-                <a:rPr sz="2200" b="0" i="0" dirty="0">
-                  <a:solidFill>
-                    <a:srgbClr val="555960"/>
-                  </a:solidFill>
-                </a:rPr>
-                <a:t>sensors and gates evaluate the result</a:t>
-              </a:r>
-            </a:p>
-          </p:txBody>
-        </p:sp>
-      </p:grpSp>
-      <p:sp>
-        <p:nvSpPr>
-          <p:cNvPr id="1023" name="Label"/>
+      <p:sp>
+        <p:nvSpPr>
+          <p:cNvPr id="1003" name="Method Problem" descr="Act III engineering method flowchart as a two-row serpentine: problem leads to model leads to judgment on the top row; judgment drops down on the right to realize, which leads left to evidence, then left to accept or reject on the lower row; a grey local-revision path hops from evidence back to realize, a gold engineering-revision path returns from evidence up to model; an alignment block from Act II sits below, governing realize and evidence"/>
           <p:cNvSpPr/>
           <p:nvPr/>
         </p:nvSpPr>
         <p:spPr>
           <a:xfrm>
-            <a:off x="365760" y="5394960"/>
-            <a:ext cx="8412480" cy="365760"/>
+            <a:off x="594360" y="1188720"/>
+            <a:ext cx="2377440" cy="1188720"/>
           </a:xfrm>
           <a:prstGeom prst="rect">
             <a:avLst/>
           </a:prstGeom>
-          <a:noFill/>
+          <a:solidFill>
+            <a:srgbClr val="8E6F3E"/>
+          </a:solidFill>
           <a:ln>
             <a:noFill/>
           </a:ln>
@@ -7766,26 +7015,358 @@
           <a:p>
             <a:pPr algn="ctr"/>
             <a:r>
-              <a:rPr sz="2200" b="0" i="1" dirty="0">
+              <a:rPr sz="2200" b="1" i="0" dirty="0">
                 <a:solidFill>
-                  <a:srgbClr val="5C4826"/>
+                  <a:srgbClr val="FFFFFF"/>
                 </a:solidFill>
               </a:rPr>
-              <a:t>We will use this method throughout Act III</a:t>
-            </a:r>
-          </a:p>
-        </p:txBody>
-      </p:sp>
-      <p:sp>
-        <p:nvSpPr>
-          <p:cNvPr id="1101" name="Local revision path"/>
+              <a:t>Problem</a:t>
+            </a:r>
+          </a:p>
+        </p:txBody>
+      </p:sp>
+      <p:sp>
+        <p:nvSpPr>
+          <p:cNvPr id="1004" name="Method Model"/>
           <p:cNvSpPr/>
           <p:nvPr/>
         </p:nvSpPr>
         <p:spPr>
           <a:xfrm>
-            <a:off x="5303520" y="1783080"/>
-            <a:ext cx="1197864" cy="365760"/>
+            <a:off x="3520440" y="1188720"/>
+            <a:ext cx="2377440" cy="1188720"/>
+          </a:xfrm>
+          <a:prstGeom prst="rect">
+            <a:avLst/>
+          </a:prstGeom>
+          <a:solidFill>
+            <a:srgbClr val="8E6F3E"/>
+          </a:solidFill>
+          <a:ln>
+            <a:noFill/>
+          </a:ln>
+          <a:effectLst/>
+        </p:spPr>
+        <p:style>
+          <a:lnRef idx="1">
+            <a:schemeClr val="accent1"/>
+          </a:lnRef>
+          <a:fillRef idx="3">
+            <a:schemeClr val="accent1"/>
+          </a:fillRef>
+          <a:effectRef idx="2">
+            <a:schemeClr val="accent1"/>
+          </a:effectRef>
+          <a:fontRef idx="minor">
+            <a:schemeClr val="lt1"/>
+          </a:fontRef>
+        </p:style>
+        <p:txBody>
+          <a:bodyPr wrap="square" lIns="27432" tIns="22860" rIns="27432" bIns="22860" rtlCol="0" anchor="ctr"/>
+          <a:lstStyle/>
+          <a:p>
+            <a:pPr algn="ctr"/>
+            <a:r>
+              <a:rPr sz="2200" b="1" i="0" dirty="0">
+                <a:solidFill>
+                  <a:srgbClr val="FFFFFF"/>
+                </a:solidFill>
+              </a:rPr>
+              <a:t>Model</a:t>
+            </a:r>
+          </a:p>
+        </p:txBody>
+      </p:sp>
+      <p:sp>
+        <p:nvSpPr>
+          <p:cNvPr id="1005" name="Method Judgment"/>
+          <p:cNvSpPr/>
+          <p:nvPr/>
+        </p:nvSpPr>
+        <p:spPr>
+          <a:xfrm>
+            <a:off x="6446520" y="1188720"/>
+            <a:ext cx="2377440" cy="1188720"/>
+          </a:xfrm>
+          <a:prstGeom prst="rect">
+            <a:avLst/>
+          </a:prstGeom>
+          <a:solidFill>
+            <a:srgbClr val="8E6F3E"/>
+          </a:solidFill>
+          <a:ln>
+            <a:noFill/>
+          </a:ln>
+          <a:effectLst/>
+        </p:spPr>
+        <p:style>
+          <a:lnRef idx="1">
+            <a:schemeClr val="accent1"/>
+          </a:lnRef>
+          <a:fillRef idx="3">
+            <a:schemeClr val="accent1"/>
+          </a:fillRef>
+          <a:effectRef idx="2">
+            <a:schemeClr val="accent1"/>
+          </a:effectRef>
+          <a:fontRef idx="minor">
+            <a:schemeClr val="lt1"/>
+          </a:fontRef>
+        </p:style>
+        <p:txBody>
+          <a:bodyPr wrap="square" lIns="27432" tIns="22860" rIns="27432" bIns="22860" rtlCol="0" anchor="ctr"/>
+          <a:lstStyle/>
+          <a:p>
+            <a:pPr algn="ctr"/>
+            <a:r>
+              <a:rPr sz="2200" b="1" i="0" dirty="0">
+                <a:solidFill>
+                  <a:srgbClr val="FFFFFF"/>
+                </a:solidFill>
+              </a:rPr>
+              <a:t>Judgment</a:t>
+            </a:r>
+          </a:p>
+        </p:txBody>
+      </p:sp>
+      <p:sp>
+        <p:nvSpPr>
+          <p:cNvPr id="1006" name="Method Realize"/>
+          <p:cNvSpPr/>
+          <p:nvPr/>
+        </p:nvSpPr>
+        <p:spPr>
+          <a:xfrm>
+            <a:off x="6446520" y="3566160"/>
+            <a:ext cx="2377440" cy="1188720"/>
+          </a:xfrm>
+          <a:prstGeom prst="rect">
+            <a:avLst/>
+          </a:prstGeom>
+          <a:solidFill>
+            <a:srgbClr val="8E6F3E"/>
+          </a:solidFill>
+          <a:ln>
+            <a:noFill/>
+          </a:ln>
+          <a:effectLst/>
+        </p:spPr>
+        <p:style>
+          <a:lnRef idx="1">
+            <a:schemeClr val="accent1"/>
+          </a:lnRef>
+          <a:fillRef idx="3">
+            <a:schemeClr val="accent1"/>
+          </a:fillRef>
+          <a:effectRef idx="2">
+            <a:schemeClr val="accent1"/>
+          </a:effectRef>
+          <a:fontRef idx="minor">
+            <a:schemeClr val="lt1"/>
+          </a:fontRef>
+        </p:style>
+        <p:txBody>
+          <a:bodyPr wrap="square" lIns="27432" tIns="22860" rIns="27432" bIns="22860" rtlCol="0" anchor="ctr"/>
+          <a:lstStyle/>
+          <a:p>
+            <a:pPr algn="ctr"/>
+            <a:r>
+              <a:rPr sz="2200" b="1" i="0" dirty="0">
+                <a:solidFill>
+                  <a:srgbClr val="FFFFFF"/>
+                </a:solidFill>
+              </a:rPr>
+              <a:t>Realize</a:t>
+            </a:r>
+          </a:p>
+        </p:txBody>
+      </p:sp>
+      <p:sp>
+        <p:nvSpPr>
+          <p:cNvPr id="1007" name="Method Evidence"/>
+          <p:cNvSpPr/>
+          <p:nvPr/>
+        </p:nvSpPr>
+        <p:spPr>
+          <a:xfrm>
+            <a:off x="3520440" y="3566160"/>
+            <a:ext cx="2377440" cy="1188720"/>
+          </a:xfrm>
+          <a:prstGeom prst="rect">
+            <a:avLst/>
+          </a:prstGeom>
+          <a:solidFill>
+            <a:srgbClr val="8E6F3E"/>
+          </a:solidFill>
+          <a:ln>
+            <a:noFill/>
+          </a:ln>
+          <a:effectLst/>
+        </p:spPr>
+        <p:style>
+          <a:lnRef idx="1">
+            <a:schemeClr val="accent1"/>
+          </a:lnRef>
+          <a:fillRef idx="3">
+            <a:schemeClr val="accent1"/>
+          </a:fillRef>
+          <a:effectRef idx="2">
+            <a:schemeClr val="accent1"/>
+          </a:effectRef>
+          <a:fontRef idx="minor">
+            <a:schemeClr val="lt1"/>
+          </a:fontRef>
+        </p:style>
+        <p:txBody>
+          <a:bodyPr wrap="square" lIns="27432" tIns="22860" rIns="27432" bIns="22860" rtlCol="0" anchor="ctr"/>
+          <a:lstStyle/>
+          <a:p>
+            <a:pPr algn="ctr"/>
+            <a:r>
+              <a:rPr sz="2200" b="1" i="0" dirty="0">
+                <a:solidFill>
+                  <a:srgbClr val="FFFFFF"/>
+                </a:solidFill>
+              </a:rPr>
+              <a:t>Evidence</a:t>
+            </a:r>
+          </a:p>
+        </p:txBody>
+      </p:sp>
+      <p:sp>
+        <p:nvSpPr>
+          <p:cNvPr id="1008" name="Method Accept / reject"/>
+          <p:cNvSpPr/>
+          <p:nvPr/>
+        </p:nvSpPr>
+        <p:spPr>
+          <a:xfrm>
+            <a:off x="594360" y="3566160"/>
+            <a:ext cx="2377440" cy="1188720"/>
+          </a:xfrm>
+          <a:prstGeom prst="rect">
+            <a:avLst/>
+          </a:prstGeom>
+          <a:solidFill>
+            <a:srgbClr val="8E6F3E"/>
+          </a:solidFill>
+          <a:ln>
+            <a:noFill/>
+          </a:ln>
+          <a:effectLst/>
+        </p:spPr>
+        <p:style>
+          <a:lnRef idx="1">
+            <a:schemeClr val="accent1"/>
+          </a:lnRef>
+          <a:fillRef idx="3">
+            <a:schemeClr val="accent1"/>
+          </a:fillRef>
+          <a:effectRef idx="2">
+            <a:schemeClr val="accent1"/>
+          </a:effectRef>
+          <a:fontRef idx="minor">
+            <a:schemeClr val="lt1"/>
+          </a:fontRef>
+        </p:style>
+        <p:txBody>
+          <a:bodyPr wrap="square" lIns="27432" tIns="22860" rIns="27432" bIns="22860" rtlCol="0" anchor="ctr"/>
+          <a:lstStyle/>
+          <a:p>
+            <a:pPr algn="ctr"/>
+            <a:r>
+              <a:rPr sz="2200" b="1" i="0" dirty="0">
+                <a:solidFill>
+                  <a:srgbClr val="FFFFFF"/>
+                </a:solidFill>
+              </a:rPr>
+              <a:t>Accept / reject</a:t>
+            </a:r>
+          </a:p>
+        </p:txBody>
+      </p:sp>
+      <p:cxnSp>
+        <p:nvCxnSpPr>
+          <p:cNvPr id="1009" name="Flow Problem to Model"/>
+          <p:cNvCxnSpPr/>
+          <p:nvPr/>
+        </p:nvCxnSpPr>
+        <p:spPr>
+          <a:xfrm>
+            <a:off x="2971800" y="1783080"/>
+            <a:ext cx="548640" cy="0"/>
+          </a:xfrm>
+          <a:prstGeom prst="line">
+            <a:avLst/>
+          </a:prstGeom>
+          <a:ln w="19050">
+            <a:solidFill>
+              <a:srgbClr val="8E6F3E"/>
+            </a:solidFill>
+            <a:tailEnd type="triangle"/>
+          </a:ln>
+        </p:spPr>
+        <p:style>
+          <a:lnRef idx="2">
+            <a:schemeClr val="accent1"/>
+          </a:lnRef>
+          <a:fillRef idx="0">
+            <a:schemeClr val="accent1"/>
+          </a:fillRef>
+          <a:effectRef idx="1">
+            <a:schemeClr val="accent1"/>
+          </a:effectRef>
+          <a:fontRef idx="minor">
+            <a:schemeClr val="tx1"/>
+          </a:fontRef>
+        </p:style>
+      </p:cxnSp>
+      <p:cxnSp>
+        <p:nvCxnSpPr>
+          <p:cNvPr id="1010" name="Flow Model to Judgment"/>
+          <p:cNvCxnSpPr/>
+          <p:nvPr/>
+        </p:nvCxnSpPr>
+        <p:spPr>
+          <a:xfrm>
+            <a:off x="5897880" y="1783080"/>
+            <a:ext cx="548640" cy="0"/>
+          </a:xfrm>
+          <a:prstGeom prst="line">
+            <a:avLst/>
+          </a:prstGeom>
+          <a:ln w="19050">
+            <a:solidFill>
+              <a:srgbClr val="8E6F3E"/>
+            </a:solidFill>
+            <a:tailEnd type="triangle"/>
+          </a:ln>
+        </p:spPr>
+        <p:style>
+          <a:lnRef idx="2">
+            <a:schemeClr val="accent1"/>
+          </a:lnRef>
+          <a:fillRef idx="0">
+            <a:schemeClr val="accent1"/>
+          </a:fillRef>
+          <a:effectRef idx="1">
+            <a:schemeClr val="accent1"/>
+          </a:effectRef>
+          <a:fontRef idx="minor">
+            <a:schemeClr val="tx1"/>
+          </a:fontRef>
+        </p:style>
+      </p:cxnSp>
+      <p:sp>
+        <p:nvSpPr>
+          <p:cNvPr id="1011" name="Flow Judgment to Realize"/>
+          <p:cNvSpPr/>
+          <p:nvPr/>
+        </p:nvSpPr>
+        <p:spPr>
+          <a:xfrm>
+            <a:off x="8823960" y="1783080"/>
+            <a:ext cx="137160" cy="2377440"/>
           </a:xfrm>
           <a:custGeom>
             <a:avLst/>
@@ -7793,18 +7374,173 @@
             <a:ahLst/>
             <a:cxnLst/>
             <a:pathLst>
-              <a:path w="1197864" h="365760" fill="none">
+              <a:path w="137160" h="2377440" fill="none">
                 <a:moveTo>
-                  <a:pt x="1197864" y="365760"/>
+                  <a:pt x="0" y="0"/>
                 </a:moveTo>
                 <a:lnTo>
-                  <a:pt x="1197864" y="0"/>
+                  <a:pt x="137160" y="0"/>
                 </a:lnTo>
+                <a:lnTo>
+                  <a:pt x="137160" y="2377440"/>
+                </a:lnTo>
+                <a:lnTo>
+                  <a:pt x="0" y="2377440"/>
+                </a:lnTo>
+              </a:path>
+            </a:pathLst>
+          </a:custGeom>
+          <a:noFill/>
+          <a:ln w="19050">
+            <a:solidFill>
+              <a:srgbClr val="8E6F3E"/>
+            </a:solidFill>
+            <a:tailEnd type="triangle"/>
+          </a:ln>
+        </p:spPr>
+        <p:txBody>
+          <a:bodyPr wrap="square" rtlCol="0"/>
+          <a:lstStyle/>
+          <a:p/>
+        </p:txBody>
+      </p:sp>
+      <p:cxnSp>
+        <p:nvCxnSpPr>
+          <p:cNvPr id="1012" name="Flow Realize to Evidence"/>
+          <p:cNvCxnSpPr/>
+          <p:nvPr/>
+        </p:nvCxnSpPr>
+        <p:spPr>
+          <a:xfrm flipH="1">
+            <a:off x="5897880" y="4160520"/>
+            <a:ext cx="548640" cy="0"/>
+          </a:xfrm>
+          <a:prstGeom prst="line">
+            <a:avLst/>
+          </a:prstGeom>
+          <a:ln w="19050">
+            <a:solidFill>
+              <a:srgbClr val="8E6F3E"/>
+            </a:solidFill>
+            <a:tailEnd type="triangle"/>
+          </a:ln>
+        </p:spPr>
+        <p:style>
+          <a:lnRef idx="2">
+            <a:schemeClr val="accent1"/>
+          </a:lnRef>
+          <a:fillRef idx="0">
+            <a:schemeClr val="accent1"/>
+          </a:fillRef>
+          <a:effectRef idx="1">
+            <a:schemeClr val="accent1"/>
+          </a:effectRef>
+          <a:fontRef idx="minor">
+            <a:schemeClr val="tx1"/>
+          </a:fontRef>
+        </p:style>
+      </p:cxnSp>
+      <p:cxnSp>
+        <p:nvCxnSpPr>
+          <p:cNvPr id="1013" name="Flow Evidence to Accept"/>
+          <p:cNvCxnSpPr/>
+          <p:nvPr/>
+        </p:nvCxnSpPr>
+        <p:spPr>
+          <a:xfrm flipH="1">
+            <a:off x="2971800" y="4160520"/>
+            <a:ext cx="548640" cy="0"/>
+          </a:xfrm>
+          <a:prstGeom prst="line">
+            <a:avLst/>
+          </a:prstGeom>
+          <a:ln w="19050">
+            <a:solidFill>
+              <a:srgbClr val="8E6F3E"/>
+            </a:solidFill>
+            <a:tailEnd type="triangle"/>
+          </a:ln>
+        </p:spPr>
+        <p:style>
+          <a:lnRef idx="2">
+            <a:schemeClr val="accent1"/>
+          </a:lnRef>
+          <a:fillRef idx="0">
+            <a:schemeClr val="accent1"/>
+          </a:fillRef>
+          <a:effectRef idx="1">
+            <a:schemeClr val="accent1"/>
+          </a:effectRef>
+          <a:fontRef idx="minor">
+            <a:schemeClr val="tx1"/>
+          </a:fontRef>
+        </p:style>
+      </p:cxnSp>
+      <p:cxnSp>
+        <p:nvCxnSpPr>
+          <p:cNvPr id="1102" name="Engineering revision path"/>
+          <p:cNvCxnSpPr/>
+          <p:nvPr/>
+        </p:nvCxnSpPr>
+        <p:spPr>
+          <a:xfrm flipV="1">
+            <a:off x="4069080" y="2377440"/>
+            <a:ext cx="0" cy="1188720"/>
+          </a:xfrm>
+          <a:prstGeom prst="line">
+            <a:avLst/>
+          </a:prstGeom>
+          <a:ln w="19050">
+            <a:solidFill>
+              <a:srgbClr val="8E6F3E"/>
+            </a:solidFill>
+            <a:tailEnd type="triangle"/>
+          </a:ln>
+        </p:spPr>
+        <p:style>
+          <a:lnRef idx="2">
+            <a:schemeClr val="accent1"/>
+          </a:lnRef>
+          <a:fillRef idx="0">
+            <a:schemeClr val="accent1"/>
+          </a:fillRef>
+          <a:effectRef idx="1">
+            <a:schemeClr val="accent1"/>
+          </a:effectRef>
+          <a:fontRef idx="minor">
+            <a:schemeClr val="tx1"/>
+          </a:fontRef>
+        </p:style>
+      </p:cxnSp>
+      <p:sp>
+        <p:nvSpPr>
+          <p:cNvPr id="1101" name="Local revision path"/>
+          <p:cNvSpPr/>
+          <p:nvPr/>
+        </p:nvSpPr>
+        <p:spPr>
+          <a:xfrm>
+            <a:off x="5349240" y="3017520"/>
+            <a:ext cx="1737360" cy="548640"/>
+          </a:xfrm>
+          <a:custGeom>
+            <a:avLst/>
+            <a:gdLst/>
+            <a:ahLst/>
+            <a:cxnLst/>
+            <a:pathLst>
+              <a:path w="1737360" h="548640" fill="none">
+                <a:moveTo>
+                  <a:pt x="0" y="548640"/>
+                </a:moveTo>
                 <a:lnTo>
                   <a:pt x="0" y="0"/>
                 </a:lnTo>
                 <a:lnTo>
-                  <a:pt x="0" y="365760"/>
+                  <a:pt x="1737360" y="0"/>
+                </a:lnTo>
+                <a:lnTo>
+                  <a:pt x="1737360" y="548640"/>
                 </a:lnTo>
               </a:path>
             </a:pathLst>
@@ -7825,61 +7561,14 @@
       </p:sp>
       <p:sp>
         <p:nvSpPr>
-          <p:cNvPr id="1102" name="Engineering revision path"/>
-          <p:cNvSpPr/>
-          <p:nvPr/>
-        </p:nvSpPr>
-        <p:spPr>
-          <a:xfrm>
-            <a:off x="2395728" y="1298448"/>
-            <a:ext cx="4617720" cy="850392"/>
-          </a:xfrm>
-          <a:custGeom>
-            <a:avLst/>
-            <a:gdLst/>
-            <a:ahLst/>
-            <a:cxnLst/>
-            <a:pathLst>
-              <a:path w="4617720" h="850392" fill="none">
-                <a:moveTo>
-                  <a:pt x="4617720" y="850392"/>
-                </a:moveTo>
-                <a:lnTo>
-                  <a:pt x="4617720" y="0"/>
-                </a:lnTo>
-                <a:lnTo>
-                  <a:pt x="0" y="0"/>
-                </a:lnTo>
-                <a:lnTo>
-                  <a:pt x="0" y="850392"/>
-                </a:lnTo>
-              </a:path>
-            </a:pathLst>
-          </a:custGeom>
-          <a:noFill/>
-          <a:ln w="19050">
-            <a:solidFill>
-              <a:srgbClr val="8E6F3E"/>
-            </a:solidFill>
-            <a:tailEnd type="triangle"/>
-          </a:ln>
-        </p:spPr>
-        <p:txBody>
-          <a:bodyPr wrap="square" rtlCol="0"/>
-          <a:lstStyle/>
-          <a:p/>
-        </p:txBody>
-      </p:sp>
-      <p:sp>
-        <p:nvSpPr>
           <p:cNvPr id="1103" name="Engineering revision label"/>
           <p:cNvSpPr/>
           <p:nvPr/>
         </p:nvSpPr>
         <p:spPr>
           <a:xfrm>
-            <a:off x="868680" y="841248"/>
-            <a:ext cx="7680960" cy="347472"/>
+            <a:off x="594360" y="2560320"/>
+            <a:ext cx="3337560" cy="914400"/>
           </a:xfrm>
           <a:prstGeom prst="rect">
             <a:avLst/>
@@ -7888,12 +7577,27 @@
           <a:ln>
             <a:noFill/>
           </a:ln>
-        </p:spPr>
+          <a:effectLst/>
+        </p:spPr>
+        <p:style>
+          <a:lnRef idx="1">
+            <a:schemeClr val="accent1"/>
+          </a:lnRef>
+          <a:fillRef idx="3">
+            <a:schemeClr val="accent1"/>
+          </a:fillRef>
+          <a:effectRef idx="2">
+            <a:schemeClr val="accent1"/>
+          </a:effectRef>
+          <a:fontRef idx="minor">
+            <a:schemeClr val="lt1"/>
+          </a:fontRef>
+        </p:style>
         <p:txBody>
           <a:bodyPr wrap="square" lIns="27432" tIns="11430" rIns="27432" bIns="11430" rtlCol="0" anchor="ctr"/>
           <a:lstStyle/>
           <a:p>
-            <a:pPr algn="ctr"/>
+            <a:pPr algn="r"/>
             <a:r>
               <a:rPr sz="2000" b="1" i="0" dirty="0">
                 <a:solidFill>
@@ -7913,8 +7617,8 @@
         </p:nvSpPr>
         <p:spPr>
           <a:xfrm>
-            <a:off x="2560320" y="1371600"/>
-            <a:ext cx="3886200" cy="329184"/>
+            <a:off x="4526280" y="2560320"/>
+            <a:ext cx="4069080" cy="365760"/>
           </a:xfrm>
           <a:prstGeom prst="rect">
             <a:avLst/>
@@ -7923,12 +7627,27 @@
           <a:ln>
             <a:noFill/>
           </a:ln>
-        </p:spPr>
+          <a:effectLst/>
+        </p:spPr>
+        <p:style>
+          <a:lnRef idx="1">
+            <a:schemeClr val="accent1"/>
+          </a:lnRef>
+          <a:fillRef idx="3">
+            <a:schemeClr val="accent1"/>
+          </a:fillRef>
+          <a:effectRef idx="2">
+            <a:schemeClr val="accent1"/>
+          </a:effectRef>
+          <a:fontRef idx="minor">
+            <a:schemeClr val="lt1"/>
+          </a:fontRef>
+        </p:style>
         <p:txBody>
           <a:bodyPr wrap="square" lIns="27432" tIns="11430" rIns="27432" bIns="11430" rtlCol="0" anchor="ctr"/>
           <a:lstStyle/>
           <a:p>
-            <a:pPr algn="r"/>
+            <a:pPr algn="ctr"/>
             <a:r>
               <a:rPr sz="2000" b="1" i="0" dirty="0">
                 <a:solidFill>
@@ -7936,6 +7655,288 @@
                 </a:solidFill>
               </a:rPr>
               <a:t>LOCAL REVISION: fix the realization</a:t>
+            </a:r>
+          </a:p>
+        </p:txBody>
+      </p:sp>
+      <p:sp>
+        <p:nvSpPr>
+          <p:cNvPr id="1018" name="Method Alignment"/>
+          <p:cNvSpPr/>
+          <p:nvPr/>
+        </p:nvSpPr>
+        <p:spPr>
+          <a:xfrm>
+            <a:off x="4343400" y="5074920"/>
+            <a:ext cx="3657600" cy="548640"/>
+          </a:xfrm>
+          <a:prstGeom prst="rect">
+            <a:avLst/>
+          </a:prstGeom>
+          <a:solidFill>
+            <a:srgbClr val="3E5C6F"/>
+          </a:solidFill>
+          <a:ln>
+            <a:noFill/>
+          </a:ln>
+          <a:effectLst/>
+        </p:spPr>
+        <p:style>
+          <a:lnRef idx="1">
+            <a:schemeClr val="accent1"/>
+          </a:lnRef>
+          <a:fillRef idx="3">
+            <a:schemeClr val="accent1"/>
+          </a:fillRef>
+          <a:effectRef idx="2">
+            <a:schemeClr val="accent1"/>
+          </a:effectRef>
+          <a:fontRef idx="minor">
+            <a:schemeClr val="lt1"/>
+          </a:fontRef>
+        </p:style>
+        <p:txBody>
+          <a:bodyPr wrap="square" lIns="27432" tIns="22860" rIns="27432" bIns="22860" rtlCol="0" anchor="ctr"/>
+          <a:lstStyle/>
+          <a:p>
+            <a:pPr algn="ctr"/>
+            <a:r>
+              <a:rPr sz="2200" b="1" i="0" dirty="0">
+                <a:solidFill>
+                  <a:srgbClr val="FFFFFF"/>
+                </a:solidFill>
+              </a:rPr>
+              <a:t>ALIGNMENT</a:t>
+            </a:r>
+            <a:r>
+              <a:rPr sz="2200" b="0" i="0" dirty="0">
+                <a:solidFill>
+                  <a:srgbClr val="FFFFFF"/>
+                </a:solidFill>
+              </a:rPr>
+              <a:t> (from Act II)</a:t>
+            </a:r>
+          </a:p>
+        </p:txBody>
+      </p:sp>
+      <p:cxnSp>
+        <p:nvCxnSpPr>
+          <p:cNvPr id="1019" name="Align to Realize"/>
+          <p:cNvCxnSpPr/>
+          <p:nvPr/>
+        </p:nvCxnSpPr>
+        <p:spPr>
+          <a:xfrm flipV="1">
+            <a:off x="7635240" y="4754880"/>
+            <a:ext cx="0" cy="320040"/>
+          </a:xfrm>
+          <a:prstGeom prst="line">
+            <a:avLst/>
+          </a:prstGeom>
+          <a:ln w="19050">
+            <a:solidFill>
+              <a:srgbClr val="8E6F3E"/>
+            </a:solidFill>
+            <a:tailEnd type="triangle"/>
+          </a:ln>
+        </p:spPr>
+        <p:style>
+          <a:lnRef idx="2">
+            <a:schemeClr val="accent1"/>
+          </a:lnRef>
+          <a:fillRef idx="0">
+            <a:schemeClr val="accent1"/>
+          </a:fillRef>
+          <a:effectRef idx="1">
+            <a:schemeClr val="accent1"/>
+          </a:effectRef>
+          <a:fontRef idx="minor">
+            <a:schemeClr val="tx1"/>
+          </a:fontRef>
+        </p:style>
+      </p:cxnSp>
+      <p:cxnSp>
+        <p:nvCxnSpPr>
+          <p:cNvPr id="1020" name="Align to Evidence"/>
+          <p:cNvCxnSpPr/>
+          <p:nvPr/>
+        </p:nvCxnSpPr>
+        <p:spPr>
+          <a:xfrm flipV="1">
+            <a:off x="4709160" y="4754880"/>
+            <a:ext cx="0" cy="320040"/>
+          </a:xfrm>
+          <a:prstGeom prst="line">
+            <a:avLst/>
+          </a:prstGeom>
+          <a:ln w="19050">
+            <a:solidFill>
+              <a:srgbClr val="8E6F3E"/>
+            </a:solidFill>
+            <a:tailEnd type="triangle"/>
+          </a:ln>
+        </p:spPr>
+        <p:style>
+          <a:lnRef idx="2">
+            <a:schemeClr val="accent1"/>
+          </a:lnRef>
+          <a:fillRef idx="0">
+            <a:schemeClr val="accent1"/>
+          </a:fillRef>
+          <a:effectRef idx="1">
+            <a:schemeClr val="accent1"/>
+          </a:effectRef>
+          <a:fontRef idx="minor">
+            <a:schemeClr val="tx1"/>
+          </a:fontRef>
+        </p:style>
+      </p:cxnSp>
+      <p:sp>
+        <p:nvSpPr>
+          <p:cNvPr id="1021" name="Align caption L"/>
+          <p:cNvSpPr/>
+          <p:nvPr/>
+        </p:nvSpPr>
+        <p:spPr>
+          <a:xfrm>
+            <a:off x="274320" y="4937760"/>
+            <a:ext cx="3977640" cy="365760"/>
+          </a:xfrm>
+          <a:prstGeom prst="rect">
+            <a:avLst/>
+          </a:prstGeom>
+          <a:noFill/>
+          <a:ln>
+            <a:noFill/>
+          </a:ln>
+          <a:effectLst/>
+        </p:spPr>
+        <p:style>
+          <a:lnRef idx="1">
+            <a:schemeClr val="accent1"/>
+          </a:lnRef>
+          <a:fillRef idx="3">
+            <a:schemeClr val="accent1"/>
+          </a:fillRef>
+          <a:effectRef idx="2">
+            <a:schemeClr val="accent1"/>
+          </a:effectRef>
+          <a:fontRef idx="minor">
+            <a:schemeClr val="lt1"/>
+          </a:fontRef>
+        </p:style>
+        <p:txBody>
+          <a:bodyPr wrap="square" lIns="27432" tIns="11430" rIns="27432" bIns="11430" rtlCol="0" anchor="ctr"/>
+          <a:lstStyle/>
+          <a:p>
+            <a:pPr algn="r"/>
+            <a:r>
+              <a:rPr sz="2000" b="0" i="0" dirty="0">
+                <a:solidFill>
+                  <a:srgbClr val="555960"/>
+                </a:solidFill>
+              </a:rPr>
+              <a:t>constraints govern realization</a:t>
+            </a:r>
+          </a:p>
+        </p:txBody>
+      </p:sp>
+      <p:sp>
+        <p:nvSpPr>
+          <p:cNvPr id="1022" name="Align caption R"/>
+          <p:cNvSpPr/>
+          <p:nvPr/>
+        </p:nvSpPr>
+        <p:spPr>
+          <a:xfrm>
+            <a:off x="274320" y="5321808"/>
+            <a:ext cx="3977640" cy="530352"/>
+          </a:xfrm>
+          <a:prstGeom prst="rect">
+            <a:avLst/>
+          </a:prstGeom>
+          <a:noFill/>
+          <a:ln>
+            <a:noFill/>
+          </a:ln>
+          <a:effectLst/>
+        </p:spPr>
+        <p:style>
+          <a:lnRef idx="1">
+            <a:schemeClr val="accent1"/>
+          </a:lnRef>
+          <a:fillRef idx="3">
+            <a:schemeClr val="accent1"/>
+          </a:fillRef>
+          <a:effectRef idx="2">
+            <a:schemeClr val="accent1"/>
+          </a:effectRef>
+          <a:fontRef idx="minor">
+            <a:schemeClr val="lt1"/>
+          </a:fontRef>
+        </p:style>
+        <p:txBody>
+          <a:bodyPr wrap="square" lIns="27432" tIns="11430" rIns="27432" bIns="11430" rtlCol="0" anchor="ctr"/>
+          <a:lstStyle/>
+          <a:p>
+            <a:pPr algn="r"/>
+            <a:r>
+              <a:rPr sz="2000" b="0" i="0" dirty="0">
+                <a:solidFill>
+                  <a:srgbClr val="555960"/>
+                </a:solidFill>
+              </a:rPr>
+              <a:t>sensors and gates evaluate the result</a:t>
+            </a:r>
+          </a:p>
+        </p:txBody>
+      </p:sp>
+      <p:sp>
+        <p:nvSpPr>
+          <p:cNvPr id="1023" name="Label"/>
+          <p:cNvSpPr/>
+          <p:nvPr/>
+        </p:nvSpPr>
+        <p:spPr>
+          <a:xfrm>
+            <a:off x="365760" y="5897880"/>
+            <a:ext cx="8412480" cy="365760"/>
+          </a:xfrm>
+          <a:prstGeom prst="rect">
+            <a:avLst/>
+          </a:prstGeom>
+          <a:noFill/>
+          <a:ln>
+            <a:noFill/>
+          </a:ln>
+          <a:effectLst/>
+        </p:spPr>
+        <p:style>
+          <a:lnRef idx="1">
+            <a:schemeClr val="accent1"/>
+          </a:lnRef>
+          <a:fillRef idx="3">
+            <a:schemeClr val="accent1"/>
+          </a:fillRef>
+          <a:effectRef idx="2">
+            <a:schemeClr val="accent1"/>
+          </a:effectRef>
+          <a:fontRef idx="minor">
+            <a:schemeClr val="lt1"/>
+          </a:fontRef>
+        </p:style>
+        <p:txBody>
+          <a:bodyPr wrap="square" lIns="27432" tIns="22860" rIns="27432" bIns="22860" rtlCol="0" anchor="ctr"/>
+          <a:lstStyle/>
+          <a:p>
+            <a:pPr algn="ctr"/>
+            <a:r>
+              <a:rPr sz="2200" b="0" i="1" dirty="0">
+                <a:solidFill>
+                  <a:srgbClr val="5C4826"/>
+                </a:solidFill>
+              </a:rPr>
+              <a:t>We will use this method throughout Act III</a:t>
             </a:r>
           </a:p>
         </p:txBody>

</xml_diff>